<commit_message>
10-minute deck: name the currencies and coins, full-sentence bullets, takeaways on slides 8 and 9
</commit_message>
<xml_diff>
--- a/slides/presentation_10min.pptx
+++ b/slides/presentation_10min.pptx
@@ -526,7 +526,12 @@
           </a:p>
           <a:p>
             <a:r>
-              <a:t>• Strategy A is G10 FX carry with a crowding filter; Strategy C is crypto funding carry.</a:t>
+              <a:t>• Strategy A is carry in seven G10 currencies against the US dollar, with a crowding filter built from CFTC data.</a:t>
+            </a:r>
+          </a:p>
+          <a:p>
+            <a:r>
+              <a:t>• Strategy C is funding carry in twelve crypto perpetual futures on Binance, including the coins that collapsed, Terra and FTX Token.</a:t>
             </a:r>
           </a:p>
         </p:txBody>
@@ -611,7 +616,7 @@
           </a:p>
           <a:p>
             <a:r>
-              <a:t>• In crypto, sorting on funding alone exposes you to single-coin collapses like LUNA and FTX.</a:t>
+              <a:t>• In crypto, sorting on funding alone exposes you to single-coin collapses like Terra and FTX Token.</a:t>
             </a:r>
           </a:p>
           <a:p>
@@ -621,7 +626,7 @@
           </a:p>
           <a:p>
             <a:r>
-              <a:t>• Main limitations: a short crypto sample, few crowded FX months, and simple cost estimates.</a:t>
+              <a:t>• The main limitations are a short crypto sample, few crowded FX months, and simple cost estimates.</a:t>
             </a:r>
           </a:p>
           <a:p>
@@ -721,12 +726,22 @@
           </a:p>
           <a:p>
             <a:r>
-              <a:t>• In FX the yield is the interest differential and we measure crowding with CFTC positions.</a:t>
-            </a:r>
-          </a:p>
-          <a:p>
-            <a:r>
-              <a:t>• In crypto the yield is the perpetual funding rate, which itself measures leveraged demand.</a:t>
+              <a:t>• In FX the yield is the interest-rate differential, and we measure crowding with CFTC speculator positions.</a:t>
+            </a:r>
+          </a:p>
+          <a:p>
+            <a:r>
+              <a:t>• Our FX universe is the yen, euro, British pound, Swiss franc, Canadian dollar, Australian dollar and New Zealand dollar, all against the US dollar.</a:t>
+            </a:r>
+          </a:p>
+          <a:p>
+            <a:r>
+              <a:t>• In crypto the yield is the perpetual funding rate, which also measures leveraged demand.</a:t>
+            </a:r>
+          </a:p>
+          <a:p>
+            <a:r>
+              <a:t>• Our coins are Bitcoin, Ethereum, BNB, XRP, Cardano, Dogecoin, Solana, Litecoin, Chainlink, Avalanche, Terra and FTX Token.</a:t>
             </a:r>
           </a:p>
           <a:p>
@@ -816,12 +831,12 @@
           </a:p>
           <a:p>
             <a:r>
-              <a:t>• Every parameter was fixed in advance, and we hold out an out-of-sample period: 2011 on for FX, 2024 on for crypto.</a:t>
-            </a:r>
-          </a:p>
-          <a:p>
-            <a:r>
-              <a:t>• Returns are net of costs, there is no look-ahead, and we keep the coins that died, LUNA and FTT.</a:t>
+              <a:t>• Every parameter was fixed in advance, and our out-of-sample period starts in 2011 for FX and in 2024 for crypto.</a:t>
+            </a:r>
+          </a:p>
+          <a:p>
+            <a:r>
+              <a:t>• Returns are net of costs, there is no look-ahead, and we keep the two coins that died, Terra (LUNA) and FTX Token (FTT).</a:t>
             </a:r>
           </a:p>
         </p:txBody>
@@ -891,12 +906,12 @@
           <a:lstStyle/>
           <a:p>
             <a:r>
-              <a:t>[about 0:50]</a:t>
-            </a:r>
-          </a:p>
-          <a:p>
-            <a:r>
-              <a:t>• Each month we rank seven currencies by their interest rate against the dollar.</a:t>
+              <a:t>[about 1:00]</a:t>
+            </a:r>
+          </a:p>
+          <a:p>
+            <a:r>
+              <a:t>• Each month we rank the seven currencies by their three-month interest rate.</a:t>
             </a:r>
           </a:p>
           <a:p>
@@ -906,6 +921,11 @@
           </a:p>
           <a:p>
             <a:r>
+              <a:t>• In practice we are almost always long the New Zealand and Australian dollars and short the Swiss franc, often with the yen or the euro.</a:t>
+            </a:r>
+          </a:p>
+          <a:p>
+            <a:r>
               <a:t>• For crowding we take speculators' net futures position and z-score it over 36 months.</a:t>
             </a:r>
           </a:p>
@@ -916,7 +936,7 @@
           </a:p>
           <a:p>
             <a:r>
-              <a:t>• Above one, we halve the position. This happened in 33 months.</a:t>
+              <a:t>• When this score is above one standard deviation, we halve the position, which happened in 33 months.</a:t>
             </a:r>
           </a:p>
         </p:txBody>
@@ -1016,7 +1036,7 @@
           </a:p>
           <a:p>
             <a:r>
-              <a:t>• Caveat: only 33 crowded months, so the effect is not precisely estimated.</a:t>
+              <a:t>• One caveat is that there are only 33 crowded months, so the effect is not precisely estimated.</a:t>
             </a:r>
           </a:p>
         </p:txBody>
@@ -1091,7 +1111,7 @@
           </a:p>
           <a:p>
             <a:r>
-              <a:t>• When does it lose? We regress monthly carry on the dollar factor and on equity-volatility shocks.</a:t>
+              <a:t>• To see when it loses, we regress monthly carry on the dollar factor and on equity-volatility shocks.</a:t>
             </a:r>
           </a:p>
           <a:p>
@@ -1106,7 +1126,7 @@
           </a:p>
           <a:p>
             <a:r>
-              <a:t>• From July 2008 to March 2009 the strategy lost 20.5% as the funding currencies, yen and Swiss franc, rallied.</a:t>
+              <a:t>• From July 2008 to March 2009 the strategy lost 20.5% as the funding currencies, the Japanese yen and the Swiss franc, rallied against the Australian and New Zealand dollars.</a:t>
             </a:r>
           </a:p>
         </p:txBody>
@@ -1196,7 +1216,12 @@
           </a:p>
           <a:p>
             <a:r>
-              <a:t>• We keep LUNA and FTT, which collapsed in 2022, to avoid survivorship bias.</a:t>
+              <a:t>• The twelve coins are Bitcoin, Ethereum, BNB, XRP, Cardano, Dogecoin, Solana, Litecoin, Chainlink, Avalanche, Terra and FTX Token.</a:t>
+            </a:r>
+          </a:p>
+          <a:p>
+            <a:r>
+              <a:t>• We keep Terra (LUNA) and FTX Token (FTT), which both collapsed in 2022, to avoid survivorship bias.</a:t>
             </a:r>
           </a:p>
           <a:p>
@@ -1206,7 +1231,7 @@
           </a:p>
           <a:p>
             <a:r>
-              <a:t>• The worst week was the LUNA collapse, -27.3%: traders were shorting LUNA, its funding turned negative, so our rule held it long.</a:t>
+              <a:t>• The worst week was the Terra (LUNA) collapse in May 2022, -27.3%: traders were shorting Terra, its funding turned negative, and so our rule held it long.</a:t>
             </a:r>
           </a:p>
         </p:txBody>
@@ -1286,7 +1311,7 @@
           </a:p>
           <a:p>
             <a:r>
-              <a:t>• But price moves dominate: in 2020 to 2023 the coins we shorted, like DOGE and XRP, kept rallying and wiped out the funding.</a:t>
+              <a:t>• But price moves dominate: in 2020 to 2023 the coins we shorted, like Dogecoin and XRP, kept rallying and wiped out the funding.</a:t>
             </a:r>
           </a:p>
           <a:p>
@@ -1296,17 +1321,22 @@
           </a:p>
           <a:p>
             <a:r>
-              <a:t>• The strategy has no market exposure; its losses come from single coins, LUNA alone -87 percentage points.</a:t>
-            </a:r>
-          </a:p>
-          <a:p>
-            <a:r>
-              <a:t>• A risk control we fixed in advance made things worse, Sharpe -0.16: the cap halved exposure and the filter missed LUNA's timing.</a:t>
-            </a:r>
-          </a:p>
-          <a:p>
-            <a:r>
-              <a:t>• So crypto carry crashes in the mirror image of FX: it ends up long whatever traders short hardest.</a:t>
+              <a:t>• The beta to Bitcoin is about zero, so the strategy has no market exposure.</a:t>
+            </a:r>
+          </a:p>
+          <a:p>
+            <a:r>
+              <a:t>• Its losses come from single coins: Terra alone cost 87 percentage points, XRP 58 and Dogecoin 43, while Solana and BNB were the biggest winners.</a:t>
+            </a:r>
+          </a:p>
+          <a:p>
+            <a:r>
+              <a:t>• A risk control we fixed in advance made things worse and lowered the Sharpe to -0.16: the cap halved exposure and the filter missed the timing of Terra's collapse.</a:t>
+            </a:r>
+          </a:p>
+          <a:p>
+            <a:r>
+              <a:t>• Our takeaway is that crypto carry crashes in the mirror image of FX: it ends up long whatever traders short hardest.</a:t>
             </a:r>
           </a:p>
         </p:txBody>
@@ -1391,12 +1421,17 @@
           </a:p>
           <a:p>
             <a:r>
-              <a:t>• The mix has 7.0% volatility and a Sharpe of 0.51, with a smaller worst month than either part.</a:t>
-            </a:r>
-          </a:p>
-          <a:p>
-            <a:r>
-              <a:t>• It does not beat FX alone on Sharpe because crypto carry was weak in this window, but the diversification is clear.</a:t>
+              <a:t>• The mix has 7.0% volatility and a Sharpe of 0.51, and its worst month, -5.9%, is smaller than either part's.</a:t>
+            </a:r>
+          </a:p>
+          <a:p>
+            <a:r>
+              <a:t>• It does not beat FX alone on Sharpe, because crypto carry was weak in this window.</a:t>
+            </a:r>
+          </a:p>
+          <a:p>
+            <a:r>
+              <a:t>• Our takeaway is that the benefit of combining them is lower risk, not a higher return.</a:t>
             </a:r>
           </a:p>
         </p:txBody>
@@ -4837,7 +4872,7 @@
                 </a:solidFill>
                 <a:latin typeface="Calibri"/>
               </a:rPr>
-              <a:t>•  Crowding predicts weaker carry and modestly improves the out-of-sample Sharpe.</a:t>
+              <a:t>•  Crowding predicts weaker carry, and the filter modestly improves the out-of-sample Sharpe.</a:t>
             </a:r>
           </a:p>
           <a:p>
@@ -4947,7 +4982,7 @@
                 </a:solidFill>
                 <a:latin typeface="Calibri"/>
               </a:rPr>
-              <a:t>•  Short crypto history (2020–2026) and only 12 coins.</a:t>
+              <a:t>•  The crypto history is short (2020–2026) and covers only 12 coins.</a:t>
             </a:r>
           </a:p>
           <a:p>
@@ -4963,7 +4998,7 @@
                 </a:solidFill>
                 <a:latin typeface="Calibri"/>
               </a:rPr>
-              <a:t>•  Few crowded FX months (33); the 2008 crash was not flagged.</a:t>
+              <a:t>•  There are only 33 crowded FX months, and the 2008 crash was not flagged.</a:t>
             </a:r>
           </a:p>
           <a:p>
@@ -4979,7 +5014,7 @@
                 </a:solidFill>
                 <a:latin typeface="Calibri"/>
               </a:rPr>
-              <a:t>•  Crypto results depend on lookback and rebalancing frequency.</a:t>
+              <a:t>•  The crypto results depend on the lookback and the rebalancing frequency.</a:t>
             </a:r>
           </a:p>
           <a:p>
@@ -4995,7 +5030,7 @@
                 </a:solidFill>
                 <a:latin typeface="Calibri"/>
               </a:rPr>
-              <a:t>•  Costs are simple estimates; no funding-rate caps, borrow limits or exchange risk.</a:t>
+              <a:t>•  Costs are simple estimates, and we ignore funding-rate caps, borrow limits and exchange risk.</a:t>
             </a:r>
           </a:p>
         </p:txBody>
@@ -5785,7 +5820,7 @@
                 </a:solidFill>
                 <a:latin typeface="Calibri"/>
               </a:rPr>
-              <a:t>12 coins incl. LUNA, FTT</a:t>
+              <a:t>12 coins (listed below)</a:t>
             </a:r>
           </a:p>
         </p:txBody>
@@ -5949,6 +5984,61 @@
                 <a:latin typeface="Calibri"/>
               </a:rPr>
               <a:t>Weekly, 2020–2026</a:t>
+            </a:r>
+          </a:p>
+        </p:txBody>
+      </p:sp>
+      <p:sp>
+        <p:nvSpPr>
+          <p:cNvPr id="23" name="TextBox 22"/>
+          <p:cNvSpPr txBox="1"/>
+          <p:nvPr/>
+        </p:nvSpPr>
+        <p:spPr>
+          <a:xfrm>
+            <a:off x="5943600" y="5257800"/>
+            <a:ext cx="5760720" cy="1371600"/>
+          </a:xfrm>
+          <a:prstGeom prst="rect">
+            <a:avLst/>
+          </a:prstGeom>
+          <a:noFill/>
+        </p:spPr>
+        <p:txBody>
+          <a:bodyPr wrap="square" anchor="t" lIns="0" rIns="0" tIns="0" bIns="0">
+            <a:spAutoFit/>
+          </a:bodyPr>
+          <a:lstStyle/>
+          <a:p>
+            <a:pPr algn="l">
+              <a:spcAft>
+                <a:spcPts val="600"/>
+              </a:spcAft>
+            </a:pPr>
+            <a:r>
+              <a:rPr sz="1100" b="0" i="0">
+                <a:solidFill>
+                  <a:srgbClr val="5C677D"/>
+                </a:solidFill>
+                <a:latin typeface="Calibri"/>
+              </a:rPr>
+              <a:t>Currencies: Japanese yen (JPY), euro (EUR), British pound (GBP), Swiss franc (CHF), Canadian dollar (CAD), Australian dollar (AUD) and New Zealand dollar (NZD), each against the US dollar.</a:t>
+            </a:r>
+          </a:p>
+          <a:p>
+            <a:pPr algn="l">
+              <a:spcAft>
+                <a:spcPts val="600"/>
+              </a:spcAft>
+            </a:pPr>
+            <a:r>
+              <a:rPr sz="1100" b="0" i="0">
+                <a:solidFill>
+                  <a:srgbClr val="5C677D"/>
+                </a:solidFill>
+                <a:latin typeface="Calibri"/>
+              </a:rPr>
+              <a:t>Coins: Bitcoin (BTC), Ethereum (ETH), BNB, XRP, Cardano (ADA), Dogecoin (DOGE), Solana (SOL), Litecoin (LTC), Chainlink (LINK), Avalanche (AVAX), Terra (LUNA) and FTX Token (FTT).</a:t>
             </a:r>
           </a:p>
         </p:txBody>
@@ -6534,97 +6624,97 @@
           <a:p>
             <a:pPr algn="l">
               <a:spcAft>
-                <a:spcPts val="1200"/>
+                <a:spcPts val="1000"/>
               </a:spcAft>
             </a:pPr>
             <a:r>
-              <a:rPr sz="1600" b="0" i="0">
+              <a:rPr sz="1500" b="0" i="0">
                 <a:solidFill>
                   <a:srgbClr val="1B1F27"/>
                 </a:solidFill>
                 <a:latin typeface="Calibri"/>
               </a:rPr>
-              <a:t>•  Parameters fixed before the first backtest</a:t>
+              <a:t>•  All parameters were fixed before the first backtest.</a:t>
             </a:r>
           </a:p>
           <a:p>
             <a:pPr algn="l">
               <a:spcAft>
-                <a:spcPts val="1200"/>
+                <a:spcPts val="1000"/>
               </a:spcAft>
             </a:pPr>
             <a:r>
-              <a:rPr sz="1600" b="0" i="0">
+              <a:rPr sz="1500" b="0" i="0">
                 <a:solidFill>
                   <a:srgbClr val="1B1F27"/>
                 </a:solidFill>
                 <a:latin typeface="Calibri"/>
               </a:rPr>
-              <a:t>•  Out-of-sample: A from 2011, C from 2024</a:t>
+              <a:t>•  The out-of-sample period starts in 2011 for A and in 2024 for C.</a:t>
             </a:r>
           </a:p>
           <a:p>
             <a:pPr algn="l">
               <a:spcAft>
-                <a:spcPts val="1200"/>
+                <a:spcPts val="1000"/>
               </a:spcAft>
             </a:pPr>
             <a:r>
-              <a:rPr sz="1600" b="0" i="0">
+              <a:rPr sz="1500" b="0" i="0">
                 <a:solidFill>
                   <a:srgbClr val="1B1F27"/>
                 </a:solidFill>
                 <a:latin typeface="Calibri"/>
               </a:rPr>
-              <a:t>•  Costs: 3 bp per unit traded in FX, 5 bp in crypto</a:t>
+              <a:t>•  Costs are 3 bp per unit traded in FX and 5 bp in crypto.</a:t>
             </a:r>
           </a:p>
           <a:p>
             <a:pPr algn="l">
               <a:spcAft>
-                <a:spcPts val="1200"/>
+                <a:spcPts val="1000"/>
               </a:spcAft>
             </a:pPr>
             <a:r>
-              <a:rPr sz="1600" b="0" i="0">
+              <a:rPr sz="1500" b="0" i="0">
                 <a:solidFill>
                   <a:srgbClr val="1B1F27"/>
                 </a:solidFill>
                 <a:latin typeface="Calibri"/>
               </a:rPr>
-              <a:t>•  No look-ahead: weights at t earn t+1; CFTC used after its Friday release</a:t>
+              <a:t>•  There is no look-ahead: weights set at t earn the return of t+1, and CFTC data are used only after their Friday release.</a:t>
             </a:r>
           </a:p>
           <a:p>
             <a:pPr algn="l">
               <a:spcAft>
-                <a:spcPts val="1200"/>
+                <a:spcPts val="1000"/>
               </a:spcAft>
             </a:pPr>
             <a:r>
-              <a:rPr sz="1600" b="0" i="0">
+              <a:rPr sz="1500" b="0" i="0">
                 <a:solidFill>
                   <a:srgbClr val="1B1F27"/>
                 </a:solidFill>
                 <a:latin typeface="Calibri"/>
               </a:rPr>
-              <a:t>•  No survivorship bias: LUNA and FTT kept</a:t>
+              <a:t>•  There is no survivorship bias, because Terra (LUNA) and FTX Token (FTT) stay in the sample.</a:t>
             </a:r>
           </a:p>
           <a:p>
             <a:pPr algn="l">
               <a:spcAft>
-                <a:spcPts val="1200"/>
+                <a:spcPts val="1000"/>
               </a:spcAft>
             </a:pPr>
             <a:r>
-              <a:rPr sz="1600" b="0" i="0">
+              <a:rPr sz="1500" b="0" i="0">
                 <a:solidFill>
                   <a:srgbClr val="1B1F27"/>
                 </a:solidFill>
                 <a:latin typeface="Calibri"/>
               </a:rPr>
-              <a:t>•  Robustness grids reported, never used for tuning</a:t>
+              <a:t>•  Robustness grids are reported, but they were never used for tuning.</a:t>
             </a:r>
           </a:p>
         </p:txBody>
@@ -6767,7 +6857,7 @@
                 </a:solidFill>
                 <a:latin typeface="Calibri"/>
               </a:rPr>
-              <a:t>JPY, EUR, GBP, CHF, CAD, AUD, NZD vs USD, monthly</a:t>
+              <a:t>Yen, euro, pound, Swiss franc, Canadian, Australian and New Zealand dollar vs USD, monthly</a:t>
             </a:r>
           </a:p>
         </p:txBody>
@@ -6897,7 +6987,7 @@
                 </a:solidFill>
                 <a:latin typeface="Calibri"/>
               </a:rPr>
-              <a:t>Each month-end: long the 2 highest-rate currencies, short the 2 lowest. Equal weights, dollar-neutral.</a:t>
+              <a:t>At each month-end we buy the 2 highest-rate currencies and sell the 2 lowest, with equal weights and no net dollar bet.</a:t>
             </a:r>
           </a:p>
         </p:txBody>
@@ -7027,7 +7117,7 @@
                 </a:solidFill>
                 <a:latin typeface="Calibri"/>
               </a:rPr>
-              <a:t>CFTC net speculative position / open interest, as a 36-month z-score.</a:t>
+              <a:t>Each currency's CFTC net speculative position over open interest is z-scored over 36 months.</a:t>
             </a:r>
           </a:p>
         </p:txBody>
@@ -7157,7 +7247,7 @@
                 </a:solidFill>
                 <a:latin typeface="Calibri"/>
               </a:rPr>
-              <a:t>Average z of the long leg minus average z of the short leg.</a:t>
+              <a:t>It is the average z of the long leg minus the average z of the short leg.</a:t>
             </a:r>
           </a:p>
         </p:txBody>
@@ -7287,7 +7377,7 @@
                 </a:solidFill>
                 <a:latin typeface="Calibri"/>
               </a:rPr>
-              <a:t>If crowding &gt; 1, cut all positions to half for the next month.</a:t>
+              <a:t>If crowding is above 1, all positions are cut to half for the next month.</a:t>
             </a:r>
           </a:p>
         </p:txBody>
@@ -7425,7 +7515,7 @@
         <p:spPr>
           <a:xfrm>
             <a:off x="7863840" y="3520440"/>
-            <a:ext cx="3749039" cy="1417320"/>
+            <a:ext cx="3749039" cy="2011680"/>
           </a:xfrm>
           <a:prstGeom prst="roundRect">
             <a:avLst>
@@ -7471,7 +7561,7 @@
         <p:spPr>
           <a:xfrm>
             <a:off x="8092440" y="3685032"/>
-            <a:ext cx="3291839" cy="685800"/>
+            <a:ext cx="3291840" cy="2286000"/>
           </a:xfrm>
           <a:prstGeom prst="rect">
             <a:avLst/>
@@ -7486,56 +7576,49 @@
           <a:p>
             <a:pPr algn="l">
               <a:spcAft>
-                <a:spcPts val="600"/>
+                <a:spcPts val="800"/>
               </a:spcAft>
             </a:pPr>
             <a:r>
-              <a:rPr sz="3400" b="1" i="0">
+              <a:rPr sz="1600" b="1" i="0">
                 <a:solidFill>
                   <a:srgbClr val="14213D"/>
                 </a:solidFill>
-                <a:latin typeface="Cambria"/>
-              </a:rPr>
-              <a:t>1 SD</a:t>
-            </a:r>
-          </a:p>
-        </p:txBody>
-      </p:sp>
-      <p:sp>
-        <p:nvSpPr>
-          <p:cNvPr id="21" name="TextBox 20"/>
-          <p:cNvSpPr txBox="1"/>
-          <p:nvPr/>
-        </p:nvSpPr>
-        <p:spPr>
-          <a:xfrm>
-            <a:off x="8092440" y="4361688"/>
-            <a:ext cx="3291839" cy="502920"/>
-          </a:xfrm>
-          <a:prstGeom prst="rect">
-            <a:avLst/>
-          </a:prstGeom>
-          <a:noFill/>
-        </p:spPr>
-        <p:txBody>
-          <a:bodyPr wrap="square" anchor="t" lIns="0" rIns="0" tIns="0" bIns="0">
-            <a:spAutoFit/>
-          </a:bodyPr>
-          <a:lstStyle/>
+                <a:latin typeface="Calibri"/>
+              </a:rPr>
+              <a:t>Who we usually hold</a:t>
+            </a:r>
+          </a:p>
           <a:p>
             <a:pPr algn="l">
               <a:spcAft>
-                <a:spcPts val="600"/>
+                <a:spcPts val="800"/>
               </a:spcAft>
             </a:pPr>
             <a:r>
-              <a:rPr sz="1200" b="0" i="0">
-                <a:solidFill>
-                  <a:srgbClr val="5C677D"/>
+              <a:rPr sz="1300" b="0" i="0">
+                <a:solidFill>
+                  <a:srgbClr val="1B1F27"/>
                 </a:solidFill>
                 <a:latin typeface="Calibri"/>
               </a:rPr>
-              <a:t>Threshold for 'crowded': one standard deviation above normal positioning</a:t>
+              <a:t>•  Long: New Zealand dollar (94% of months) and Australian dollar (75%).</a:t>
+            </a:r>
+          </a:p>
+          <a:p>
+            <a:pPr algn="l">
+              <a:spcAft>
+                <a:spcPts val="800"/>
+              </a:spcAft>
+            </a:pPr>
+            <a:r>
+              <a:rPr sz="1300" b="0" i="0">
+                <a:solidFill>
+                  <a:srgbClr val="1B1F27"/>
+                </a:solidFill>
+                <a:latin typeface="Calibri"/>
+              </a:rPr>
+              <a:t>•  Short: Swiss franc (99%), Japanese yen (52%) and euro (40%).</a:t>
             </a:r>
           </a:p>
         </p:txBody>
@@ -8841,7 +8924,7 @@
                 </a:solidFill>
                 <a:latin typeface="Calibri"/>
               </a:rPr>
-              <a:t>12 Binance perpetuals incl. LUNA and FTT, weekly, 2020–2026</a:t>
+              <a:t>Binance perpetuals on BTC, ETH, BNB, XRP, ADA, DOGE, SOL, LTC, LINK, AVAX, LUNA, FTT; weekly, 2020–2026</a:t>
             </a:r>
           </a:p>
         </p:txBody>
@@ -8904,7 +8987,7 @@
                 </a:solidFill>
                 <a:latin typeface="Calibri"/>
               </a:rPr>
-              <a:t>•  Funding is paid every 8 hours; positive funding means longs pay shorts.</a:t>
+              <a:t>•  Funding is paid every 8 hours, and positive funding means longs pay shorts.</a:t>
             </a:r>
           </a:p>
           <a:p>
@@ -8920,7 +9003,7 @@
                 </a:solidFill>
                 <a:latin typeface="Calibri"/>
               </a:rPr>
-              <a:t>•  Each Sunday: short the third of coins with the highest 7-day funding, long the lowest third.</a:t>
+              <a:t>•  Each Sunday we short the third of coins with the highest 7-day funding and buy the lowest third.</a:t>
             </a:r>
           </a:p>
           <a:p>
@@ -8936,7 +9019,7 @@
                 </a:solidFill>
                 <a:latin typeface="Calibri"/>
               </a:rPr>
-              <a:t>•  Dollar-neutral, 5 bp costs.</a:t>
+              <a:t>•  The book is dollar-neutral and pays 5 bp per trade.</a:t>
             </a:r>
           </a:p>
         </p:txBody>
@@ -9853,8 +9936,8 @@
         </p:nvSpPr>
         <p:spPr>
           <a:xfrm>
-            <a:off x="6309360" y="3246120"/>
-            <a:ext cx="5394960" cy="3108960"/>
+            <a:off x="548640" y="5257800"/>
+            <a:ext cx="5394960" cy="1188720"/>
           </a:xfrm>
           <a:prstGeom prst="rect">
             <a:avLst/>
@@ -9869,65 +9952,205 @@
           <a:p>
             <a:pPr algn="l">
               <a:spcAft>
-                <a:spcPts val="1000"/>
+                <a:spcPts val="600"/>
               </a:spcAft>
             </a:pPr>
             <a:r>
-              <a:rPr sz="1400" b="0" i="0">
-                <a:solidFill>
-                  <a:srgbClr val="1B1F27"/>
+              <a:rPr sz="1200" b="0" i="0">
+                <a:solidFill>
+                  <a:srgbClr val="5C677D"/>
                 </a:solidFill>
                 <a:latin typeface="Calibri"/>
               </a:rPr>
-              <a:t>•  Beta to BTC ≈ -0.02 (t = -0.75): market-neutral.</a:t>
-            </a:r>
-          </a:p>
+              <a:t>Total P&amp;L by coin, % pts: Solana +102, BNB +51, Avalanche +36; Terra -87, XRP -58, Dogecoin -43, FTX Token -13.</a:t>
+            </a:r>
+          </a:p>
+        </p:txBody>
+      </p:sp>
+      <p:sp>
+        <p:nvSpPr>
+          <p:cNvPr id="7" name="Rounded Rectangle 6"/>
+          <p:cNvSpPr/>
+          <p:nvPr/>
+        </p:nvSpPr>
+        <p:spPr>
+          <a:xfrm>
+            <a:off x="6309360" y="3200400"/>
+            <a:ext cx="5394960" cy="3337560"/>
+          </a:xfrm>
+          <a:prstGeom prst="roundRect">
+            <a:avLst>
+              <a:gd name="adj" fmla="val 8000"/>
+            </a:avLst>
+          </a:prstGeom>
+          <a:solidFill>
+            <a:srgbClr val="EEF1F6"/>
+          </a:solidFill>
+          <a:ln>
+            <a:noFill/>
+          </a:ln>
+          <a:effectLst/>
+        </p:spPr>
+        <p:style>
+          <a:lnRef idx="1">
+            <a:schemeClr val="accent1"/>
+          </a:lnRef>
+          <a:fillRef idx="3">
+            <a:schemeClr val="accent1"/>
+          </a:fillRef>
+          <a:effectRef idx="2">
+            <a:schemeClr val="accent1"/>
+          </a:effectRef>
+          <a:fontRef idx="minor">
+            <a:schemeClr val="lt1"/>
+          </a:fontRef>
+        </p:style>
+        <p:txBody>
+          <a:bodyPr rtlCol="0" anchor="ctr"/>
+          <a:lstStyle/>
+          <a:p>
+            <a:pPr algn="ctr"/>
+          </a:p>
+        </p:txBody>
+      </p:sp>
+      <p:sp>
+        <p:nvSpPr>
+          <p:cNvPr id="8" name="TextBox 7"/>
+          <p:cNvSpPr txBox="1"/>
+          <p:nvPr/>
+        </p:nvSpPr>
+        <p:spPr>
+          <a:xfrm>
+            <a:off x="6537960" y="3364992"/>
+            <a:ext cx="4937760" cy="365760"/>
+          </a:xfrm>
+          <a:prstGeom prst="rect">
+            <a:avLst/>
+          </a:prstGeom>
+          <a:noFill/>
+        </p:spPr>
+        <p:txBody>
+          <a:bodyPr wrap="square" anchor="t" lIns="0" rIns="0" tIns="0" bIns="0">
+            <a:spAutoFit/>
+          </a:bodyPr>
+          <a:lstStyle/>
           <a:p>
             <a:pPr algn="l">
               <a:spcAft>
-                <a:spcPts val="1000"/>
+                <a:spcPts val="600"/>
               </a:spcAft>
             </a:pPr>
             <a:r>
-              <a:rPr sz="1400" b="0" i="0">
-                <a:solidFill>
-                  <a:srgbClr val="1B1F27"/>
+              <a:rPr sz="1600" b="1" i="0">
+                <a:solidFill>
+                  <a:srgbClr val="14213D"/>
                 </a:solidFill>
                 <a:latin typeface="Calibri"/>
               </a:rPr>
-              <a:t>•  Losses are coin-specific: LUNA -87, XRP -58, DOGE -43 % pts.</a:t>
-            </a:r>
-          </a:p>
+              <a:t>Takeaways</a:t>
+            </a:r>
+          </a:p>
+        </p:txBody>
+      </p:sp>
+      <p:sp>
+        <p:nvSpPr>
+          <p:cNvPr id="9" name="TextBox 8"/>
+          <p:cNvSpPr txBox="1"/>
+          <p:nvPr/>
+        </p:nvSpPr>
+        <p:spPr>
+          <a:xfrm>
+            <a:off x="6537960" y="3794760"/>
+            <a:ext cx="4937760" cy="2606039"/>
+          </a:xfrm>
+          <a:prstGeom prst="rect">
+            <a:avLst/>
+          </a:prstGeom>
+          <a:noFill/>
+        </p:spPr>
+        <p:txBody>
+          <a:bodyPr wrap="square" anchor="t" lIns="0" rIns="0" tIns="0" bIns="0">
+            <a:spAutoFit/>
+          </a:bodyPr>
+          <a:lstStyle/>
           <a:p>
             <a:pPr algn="l">
               <a:spcAft>
-                <a:spcPts val="1000"/>
+                <a:spcPts val="800"/>
               </a:spcAft>
             </a:pPr>
             <a:r>
-              <a:rPr sz="1400" b="0" i="0">
+              <a:rPr sz="1300" b="0" i="0">
                 <a:solidFill>
                   <a:srgbClr val="1B1F27"/>
                 </a:solidFill>
                 <a:latin typeface="Calibri"/>
               </a:rPr>
-              <a:t>•  Pre-set risk control (1/6 cap, no longs below −50% funding): Sharpe 0.14 → -0.16. It did not help.</a:t>
+              <a:t>•  Funding income is steady at about 8.5% a year, but price moves decide the result.</a:t>
             </a:r>
           </a:p>
           <a:p>
             <a:pPr algn="l">
               <a:spcAft>
-                <a:spcPts val="1000"/>
+                <a:spcPts val="800"/>
               </a:spcAft>
             </a:pPr>
             <a:r>
-              <a:rPr sz="1400" b="1" i="0">
-                <a:solidFill>
-                  <a:srgbClr val="14213D"/>
+              <a:rPr sz="1300" b="0" i="0">
+                <a:solidFill>
+                  <a:srgbClr val="1B1F27"/>
                 </a:solidFill>
                 <a:latin typeface="Calibri"/>
               </a:rPr>
-              <a:t>•  Lesson: deeply negative funding means crowded shorts, not distress.</a:t>
+              <a:t>•  The strategy has no market exposure, since its beta to Bitcoin is -0.02.</a:t>
+            </a:r>
+          </a:p>
+          <a:p>
+            <a:pPr algn="l">
+              <a:spcAft>
+                <a:spcPts val="800"/>
+              </a:spcAft>
+            </a:pPr>
+            <a:r>
+              <a:rPr sz="1300" b="0" i="0">
+                <a:solidFill>
+                  <a:srgbClr val="1B1F27"/>
+                </a:solidFill>
+                <a:latin typeface="Calibri"/>
+              </a:rPr>
+              <a:t>•  Its losses come from single coins: Terra lost 87 points, XRP 58 and Dogecoin 43.</a:t>
+            </a:r>
+          </a:p>
+          <a:p>
+            <a:pPr algn="l">
+              <a:spcAft>
+                <a:spcPts val="800"/>
+              </a:spcAft>
+            </a:pPr>
+            <a:r>
+              <a:rPr sz="1300" b="0" i="0">
+                <a:solidFill>
+                  <a:srgbClr val="1B1F27"/>
+                </a:solidFill>
+                <a:latin typeface="Calibri"/>
+              </a:rPr>
+              <a:t>•  Our pre-set risk control lowered the Sharpe from 0.14 to -0.16, so it did not help.</a:t>
+            </a:r>
+          </a:p>
+          <a:p>
+            <a:pPr algn="l">
+              <a:spcAft>
+                <a:spcPts val="800"/>
+              </a:spcAft>
+            </a:pPr>
+            <a:r>
+              <a:rPr sz="1300" b="0" i="0">
+                <a:solidFill>
+                  <a:srgbClr val="1B1F27"/>
+                </a:solidFill>
+                <a:latin typeface="Calibri"/>
+              </a:rPr>
+              <a:t>•  Deeply negative funding signals crowded shorts, not a cheap coin.</a:t>
             </a:r>
           </a:p>
         </p:txBody>
@@ -10052,149 +10275,25 @@
         </p:blipFill>
         <p:spPr>
           <a:xfrm>
-            <a:off x="457200" y="1691640"/>
-            <a:ext cx="7132320" cy="3922776"/>
+            <a:off x="457200" y="1600200"/>
+            <a:ext cx="6035040" cy="3319272"/>
           </a:xfrm>
           <a:prstGeom prst="rect">
             <a:avLst/>
           </a:prstGeom>
         </p:spPr>
       </p:pic>
-      <p:sp>
-        <p:nvSpPr>
-          <p:cNvPr id="5" name="Rounded Rectangle 4"/>
-          <p:cNvSpPr/>
-          <p:nvPr/>
-        </p:nvSpPr>
-        <p:spPr>
-          <a:xfrm>
-            <a:off x="8001000" y="1783080"/>
-            <a:ext cx="3657600" cy="1417320"/>
-          </a:xfrm>
-          <a:prstGeom prst="roundRect">
-            <a:avLst>
-              <a:gd name="adj" fmla="val 8000"/>
-            </a:avLst>
-          </a:prstGeom>
-          <a:solidFill>
-            <a:srgbClr val="EEF1F6"/>
-          </a:solidFill>
-          <a:ln>
-            <a:noFill/>
-          </a:ln>
-          <a:effectLst/>
-        </p:spPr>
-        <p:style>
-          <a:lnRef idx="1">
-            <a:schemeClr val="accent1"/>
-          </a:lnRef>
-          <a:fillRef idx="3">
-            <a:schemeClr val="accent1"/>
-          </a:fillRef>
-          <a:effectRef idx="2">
-            <a:schemeClr val="accent1"/>
-          </a:effectRef>
-          <a:fontRef idx="minor">
-            <a:schemeClr val="lt1"/>
-          </a:fontRef>
-        </p:style>
-        <p:txBody>
-          <a:bodyPr rtlCol="0" anchor="ctr"/>
-          <a:lstStyle/>
-          <a:p>
-            <a:pPr algn="ctr"/>
-          </a:p>
-        </p:txBody>
-      </p:sp>
-      <p:sp>
-        <p:nvSpPr>
-          <p:cNvPr id="6" name="TextBox 5"/>
-          <p:cNvSpPr txBox="1"/>
-          <p:nvPr/>
-        </p:nvSpPr>
-        <p:spPr>
-          <a:xfrm>
-            <a:off x="8229600" y="1947672"/>
-            <a:ext cx="3200400" cy="685800"/>
-          </a:xfrm>
-          <a:prstGeom prst="rect">
-            <a:avLst/>
-          </a:prstGeom>
-          <a:noFill/>
-        </p:spPr>
-        <p:txBody>
-          <a:bodyPr wrap="square" anchor="t" lIns="0" rIns="0" tIns="0" bIns="0">
-            <a:spAutoFit/>
-          </a:bodyPr>
-          <a:lstStyle/>
-          <a:p>
-            <a:pPr algn="l">
-              <a:spcAft>
-                <a:spcPts val="600"/>
-              </a:spcAft>
-            </a:pPr>
-            <a:r>
-              <a:rPr sz="3400" b="1" i="0">
-                <a:solidFill>
-                  <a:srgbClr val="14213D"/>
-                </a:solidFill>
-                <a:latin typeface="Cambria"/>
-              </a:rPr>
-              <a:t>0.11</a:t>
-            </a:r>
-          </a:p>
-        </p:txBody>
-      </p:sp>
-      <p:sp>
-        <p:nvSpPr>
-          <p:cNvPr id="7" name="TextBox 6"/>
-          <p:cNvSpPr txBox="1"/>
-          <p:nvPr/>
-        </p:nvSpPr>
-        <p:spPr>
-          <a:xfrm>
-            <a:off x="8229600" y="2624328"/>
-            <a:ext cx="3200400" cy="502920"/>
-          </a:xfrm>
-          <a:prstGeom prst="rect">
-            <a:avLst/>
-          </a:prstGeom>
-          <a:noFill/>
-        </p:spPr>
-        <p:txBody>
-          <a:bodyPr wrap="square" anchor="t" lIns="0" rIns="0" tIns="0" bIns="0">
-            <a:spAutoFit/>
-          </a:bodyPr>
-          <a:lstStyle/>
-          <a:p>
-            <a:pPr algn="l">
-              <a:spcAft>
-                <a:spcPts val="600"/>
-              </a:spcAft>
-            </a:pPr>
-            <a:r>
-              <a:rPr sz="1200" b="0" i="0">
-                <a:solidFill>
-                  <a:srgbClr val="5C677D"/>
-                </a:solidFill>
-                <a:latin typeface="Calibri"/>
-              </a:rPr>
-              <a:t>Correlation between A and C</a:t>
-            </a:r>
-          </a:p>
-        </p:txBody>
-      </p:sp>
       <p:graphicFrame>
         <p:nvGraphicFramePr>
-          <p:cNvPr id="8" name="Table 7"/>
+          <p:cNvPr id="5" name="Table 4"/>
           <p:cNvGraphicFramePr>
             <a:graphicFrameLocks noGrp="1"/>
           </p:cNvGraphicFramePr>
           <p:nvPr/>
         </p:nvGraphicFramePr>
         <p:xfrm>
-          <a:off x="8001000" y="3429000"/>
-          <a:ext cx="3657600" cy="1316736"/>
+          <a:off x="548640" y="4937760"/>
+          <a:ext cx="5852160" cy="1243584"/>
         </p:xfrm>
         <a:graphic>
           <a:graphicData uri="http://schemas.openxmlformats.org/drawingml/2006/table">
@@ -10203,12 +10302,13 @@
                 <a:tableStyleId>{5C22544A-7EE6-4342-B048-85BDC9FD1C3A}</a:tableStyleId>
               </a:tblPr>
               <a:tblGrid>
+                <a:gridCol w="1463040"/>
+                <a:gridCol w="822960"/>
+                <a:gridCol w="822960"/>
                 <a:gridCol w="1188720"/>
-                <a:gridCol w="731520"/>
-                <a:gridCol w="731520"/>
-                <a:gridCol w="1005840"/>
+                <a:gridCol w="1554480"/>
               </a:tblGrid>
-              <a:tr h="329184">
+              <a:tr h="310896">
                 <a:tc>
                   <a:txBody>
                     <a:bodyPr/>
@@ -10291,7 +10391,30 @@
                           </a:solidFill>
                           <a:latin typeface="Calibri"/>
                         </a:rPr>
-                        <a:t>MaxDD (%)</a:t>
+                        <a:t>Max DD (%)</a:t>
+                      </a:r>
+                    </a:p>
+                  </a:txBody>
+                  <a:tcPr marL="73152" marR="73152">
+                    <a:solidFill>
+                      <a:srgbClr val="14213D"/>
+                    </a:solidFill>
+                  </a:tcPr>
+                </a:tc>
+                <a:tc>
+                  <a:txBody>
+                    <a:bodyPr/>
+                    <a:lstStyle/>
+                    <a:p>
+                      <a:pPr algn="r"/>
+                      <a:r>
+                        <a:rPr sz="1200" b="1">
+                          <a:solidFill>
+                            <a:srgbClr val="FFFFFF"/>
+                          </a:solidFill>
+                          <a:latin typeface="Calibri"/>
+                        </a:rPr>
+                        <a:t>Worst month (%)</a:t>
                       </a:r>
                     </a:p>
                   </a:txBody>
@@ -10302,7 +10425,7 @@
                   </a:tcPr>
                 </a:tc>
               </a:tr>
-              <a:tr h="329184">
+              <a:tr h="310896">
                 <a:tc>
                   <a:txBody>
                     <a:bodyPr/>
@@ -10395,8 +10518,31 @@
                     </a:solidFill>
                   </a:tcPr>
                 </a:tc>
+                <a:tc>
+                  <a:txBody>
+                    <a:bodyPr/>
+                    <a:lstStyle/>
+                    <a:p>
+                      <a:pPr algn="r"/>
+                      <a:r>
+                        <a:rPr sz="1200" b="0">
+                          <a:solidFill>
+                            <a:srgbClr val="1B1F27"/>
+                          </a:solidFill>
+                          <a:latin typeface="Calibri"/>
+                        </a:rPr>
+                        <a:t>-7.4</a:t>
+                      </a:r>
+                    </a:p>
+                  </a:txBody>
+                  <a:tcPr marL="73152" marR="73152">
+                    <a:solidFill>
+                      <a:srgbClr val="FFFFFF"/>
+                    </a:solidFill>
+                  </a:tcPr>
+                </a:tc>
               </a:tr>
-              <a:tr h="329184">
+              <a:tr h="310896">
                 <a:tc>
                   <a:txBody>
                     <a:bodyPr/>
@@ -10489,8 +10635,31 @@
                     </a:solidFill>
                   </a:tcPr>
                 </a:tc>
+                <a:tc>
+                  <a:txBody>
+                    <a:bodyPr/>
+                    <a:lstStyle/>
+                    <a:p>
+                      <a:pPr algn="r"/>
+                      <a:r>
+                        <a:rPr sz="1200" b="0">
+                          <a:solidFill>
+                            <a:srgbClr val="1B1F27"/>
+                          </a:solidFill>
+                          <a:latin typeface="Calibri"/>
+                        </a:rPr>
+                        <a:t>-10.2</a:t>
+                      </a:r>
+                    </a:p>
+                  </a:txBody>
+                  <a:tcPr marL="73152" marR="73152">
+                    <a:solidFill>
+                      <a:srgbClr val="EEF1F6"/>
+                    </a:solidFill>
+                  </a:tcPr>
+                </a:tc>
               </a:tr>
-              <a:tr h="329184">
+              <a:tr h="310896">
                 <a:tc>
                   <a:txBody>
                     <a:bodyPr/>
@@ -10583,11 +10752,330 @@
                     </a:solidFill>
                   </a:tcPr>
                 </a:tc>
+                <a:tc>
+                  <a:txBody>
+                    <a:bodyPr/>
+                    <a:lstStyle/>
+                    <a:p>
+                      <a:pPr algn="r"/>
+                      <a:r>
+                        <a:rPr sz="1200" b="0">
+                          <a:solidFill>
+                            <a:srgbClr val="1B1F27"/>
+                          </a:solidFill>
+                          <a:latin typeface="Calibri"/>
+                        </a:rPr>
+                        <a:t>-5.9</a:t>
+                      </a:r>
+                    </a:p>
+                  </a:txBody>
+                  <a:tcPr marL="73152" marR="73152">
+                    <a:solidFill>
+                      <a:srgbClr val="FFFFFF"/>
+                    </a:solidFill>
+                  </a:tcPr>
+                </a:tc>
               </a:tr>
             </a:tbl>
           </a:graphicData>
         </a:graphic>
       </p:graphicFrame>
+      <p:sp>
+        <p:nvSpPr>
+          <p:cNvPr id="6" name="Rounded Rectangle 5"/>
+          <p:cNvSpPr/>
+          <p:nvPr/>
+        </p:nvSpPr>
+        <p:spPr>
+          <a:xfrm>
+            <a:off x="6858000" y="1645920"/>
+            <a:ext cx="4800600" cy="1280160"/>
+          </a:xfrm>
+          <a:prstGeom prst="roundRect">
+            <a:avLst>
+              <a:gd name="adj" fmla="val 8000"/>
+            </a:avLst>
+          </a:prstGeom>
+          <a:solidFill>
+            <a:srgbClr val="EEF1F6"/>
+          </a:solidFill>
+          <a:ln>
+            <a:noFill/>
+          </a:ln>
+          <a:effectLst/>
+        </p:spPr>
+        <p:style>
+          <a:lnRef idx="1">
+            <a:schemeClr val="accent1"/>
+          </a:lnRef>
+          <a:fillRef idx="3">
+            <a:schemeClr val="accent1"/>
+          </a:fillRef>
+          <a:effectRef idx="2">
+            <a:schemeClr val="accent1"/>
+          </a:effectRef>
+          <a:fontRef idx="minor">
+            <a:schemeClr val="lt1"/>
+          </a:fontRef>
+        </p:style>
+        <p:txBody>
+          <a:bodyPr rtlCol="0" anchor="ctr"/>
+          <a:lstStyle/>
+          <a:p>
+            <a:pPr algn="ctr"/>
+          </a:p>
+        </p:txBody>
+      </p:sp>
+      <p:sp>
+        <p:nvSpPr>
+          <p:cNvPr id="7" name="TextBox 6"/>
+          <p:cNvSpPr txBox="1"/>
+          <p:nvPr/>
+        </p:nvSpPr>
+        <p:spPr>
+          <a:xfrm>
+            <a:off x="7086600" y="1810512"/>
+            <a:ext cx="4343400" cy="685800"/>
+          </a:xfrm>
+          <a:prstGeom prst="rect">
+            <a:avLst/>
+          </a:prstGeom>
+          <a:noFill/>
+        </p:spPr>
+        <p:txBody>
+          <a:bodyPr wrap="square" anchor="t" lIns="0" rIns="0" tIns="0" bIns="0">
+            <a:spAutoFit/>
+          </a:bodyPr>
+          <a:lstStyle/>
+          <a:p>
+            <a:pPr algn="l">
+              <a:spcAft>
+                <a:spcPts val="600"/>
+              </a:spcAft>
+            </a:pPr>
+            <a:r>
+              <a:rPr sz="3400" b="1" i="0">
+                <a:solidFill>
+                  <a:srgbClr val="14213D"/>
+                </a:solidFill>
+                <a:latin typeface="Cambria"/>
+              </a:rPr>
+              <a:t>0.11</a:t>
+            </a:r>
+          </a:p>
+        </p:txBody>
+      </p:sp>
+      <p:sp>
+        <p:nvSpPr>
+          <p:cNvPr id="8" name="TextBox 7"/>
+          <p:cNvSpPr txBox="1"/>
+          <p:nvPr/>
+        </p:nvSpPr>
+        <p:spPr>
+          <a:xfrm>
+            <a:off x="7086600" y="2487168"/>
+            <a:ext cx="4343400" cy="365759"/>
+          </a:xfrm>
+          <a:prstGeom prst="rect">
+            <a:avLst/>
+          </a:prstGeom>
+          <a:noFill/>
+        </p:spPr>
+        <p:txBody>
+          <a:bodyPr wrap="square" anchor="t" lIns="0" rIns="0" tIns="0" bIns="0">
+            <a:spAutoFit/>
+          </a:bodyPr>
+          <a:lstStyle/>
+          <a:p>
+            <a:pPr algn="l">
+              <a:spcAft>
+                <a:spcPts val="600"/>
+              </a:spcAft>
+            </a:pPr>
+            <a:r>
+              <a:rPr sz="1200" b="0" i="0">
+                <a:solidFill>
+                  <a:srgbClr val="5C677D"/>
+                </a:solidFill>
+                <a:latin typeface="Calibri"/>
+              </a:rPr>
+              <a:t>Correlation between A and C, monthly, 2021–2026</a:t>
+            </a:r>
+          </a:p>
+        </p:txBody>
+      </p:sp>
+      <p:sp>
+        <p:nvSpPr>
+          <p:cNvPr id="9" name="Rounded Rectangle 8"/>
+          <p:cNvSpPr/>
+          <p:nvPr/>
+        </p:nvSpPr>
+        <p:spPr>
+          <a:xfrm>
+            <a:off x="6858000" y="3108960"/>
+            <a:ext cx="4800600" cy="3429000"/>
+          </a:xfrm>
+          <a:prstGeom prst="roundRect">
+            <a:avLst>
+              <a:gd name="adj" fmla="val 8000"/>
+            </a:avLst>
+          </a:prstGeom>
+          <a:solidFill>
+            <a:srgbClr val="EEF1F6"/>
+          </a:solidFill>
+          <a:ln>
+            <a:noFill/>
+          </a:ln>
+          <a:effectLst/>
+        </p:spPr>
+        <p:style>
+          <a:lnRef idx="1">
+            <a:schemeClr val="accent1"/>
+          </a:lnRef>
+          <a:fillRef idx="3">
+            <a:schemeClr val="accent1"/>
+          </a:fillRef>
+          <a:effectRef idx="2">
+            <a:schemeClr val="accent1"/>
+          </a:effectRef>
+          <a:fontRef idx="minor">
+            <a:schemeClr val="lt1"/>
+          </a:fontRef>
+        </p:style>
+        <p:txBody>
+          <a:bodyPr rtlCol="0" anchor="ctr"/>
+          <a:lstStyle/>
+          <a:p>
+            <a:pPr algn="ctr"/>
+          </a:p>
+        </p:txBody>
+      </p:sp>
+      <p:sp>
+        <p:nvSpPr>
+          <p:cNvPr id="10" name="TextBox 9"/>
+          <p:cNvSpPr txBox="1"/>
+          <p:nvPr/>
+        </p:nvSpPr>
+        <p:spPr>
+          <a:xfrm>
+            <a:off x="7086600" y="3273552"/>
+            <a:ext cx="4343400" cy="365760"/>
+          </a:xfrm>
+          <a:prstGeom prst="rect">
+            <a:avLst/>
+          </a:prstGeom>
+          <a:noFill/>
+        </p:spPr>
+        <p:txBody>
+          <a:bodyPr wrap="square" anchor="t" lIns="0" rIns="0" tIns="0" bIns="0">
+            <a:spAutoFit/>
+          </a:bodyPr>
+          <a:lstStyle/>
+          <a:p>
+            <a:pPr algn="l">
+              <a:spcAft>
+                <a:spcPts val="600"/>
+              </a:spcAft>
+            </a:pPr>
+            <a:r>
+              <a:rPr sz="1600" b="1" i="0">
+                <a:solidFill>
+                  <a:srgbClr val="14213D"/>
+                </a:solidFill>
+                <a:latin typeface="Calibri"/>
+              </a:rPr>
+              <a:t>Takeaways</a:t>
+            </a:r>
+          </a:p>
+        </p:txBody>
+      </p:sp>
+      <p:sp>
+        <p:nvSpPr>
+          <p:cNvPr id="11" name="TextBox 10"/>
+          <p:cNvSpPr txBox="1"/>
+          <p:nvPr/>
+        </p:nvSpPr>
+        <p:spPr>
+          <a:xfrm>
+            <a:off x="7086600" y="3703320"/>
+            <a:ext cx="4343400" cy="2697480"/>
+          </a:xfrm>
+          <a:prstGeom prst="rect">
+            <a:avLst/>
+          </a:prstGeom>
+          <a:noFill/>
+        </p:spPr>
+        <p:txBody>
+          <a:bodyPr wrap="square" anchor="t" lIns="0" rIns="0" tIns="0" bIns="0">
+            <a:spAutoFit/>
+          </a:bodyPr>
+          <a:lstStyle/>
+          <a:p>
+            <a:pPr algn="l">
+              <a:spcAft>
+                <a:spcPts val="800"/>
+              </a:spcAft>
+            </a:pPr>
+            <a:r>
+              <a:rPr sz="1300" b="0" i="0">
+                <a:solidFill>
+                  <a:srgbClr val="1B1F27"/>
+                </a:solidFill>
+                <a:latin typeface="Calibri"/>
+              </a:rPr>
+              <a:t>•  FX carry and crypto carry are almost uncorrelated, so they crash at different times.</a:t>
+            </a:r>
+          </a:p>
+          <a:p>
+            <a:pPr algn="l">
+              <a:spcAft>
+                <a:spcPts val="800"/>
+              </a:spcAft>
+            </a:pPr>
+            <a:r>
+              <a:rPr sz="1300" b="0" i="0">
+                <a:solidFill>
+                  <a:srgbClr val="1B1F27"/>
+                </a:solidFill>
+                <a:latin typeface="Calibri"/>
+              </a:rPr>
+              <a:t>•  The 50/50 mix has 7.0% volatility, compared with about 9% for each strategy alone.</a:t>
+            </a:r>
+          </a:p>
+          <a:p>
+            <a:pPr algn="l">
+              <a:spcAft>
+                <a:spcPts val="800"/>
+              </a:spcAft>
+            </a:pPr>
+            <a:r>
+              <a:rPr sz="1300" b="0" i="0">
+                <a:solidFill>
+                  <a:srgbClr val="1B1F27"/>
+                </a:solidFill>
+                <a:latin typeface="Calibri"/>
+              </a:rPr>
+              <a:t>•  Its worst month is -5.9%, smaller than for FX (-7.4%) or crypto (-10.2%).</a:t>
+            </a:r>
+          </a:p>
+          <a:p>
+            <a:pPr algn="l">
+              <a:spcAft>
+                <a:spcPts val="800"/>
+              </a:spcAft>
+            </a:pPr>
+            <a:r>
+              <a:rPr sz="1300" b="0" i="0">
+                <a:solidFill>
+                  <a:srgbClr val="1B1F27"/>
+                </a:solidFill>
+                <a:latin typeface="Calibri"/>
+              </a:rPr>
+              <a:t>•  The mix does not beat FX alone on Sharpe (0.51 vs 0.71), because crypto carry was weak in this window.</a:t>
+            </a:r>
+          </a:p>
+        </p:txBody>
+      </p:sp>
     </p:spTree>
   </p:cSld>
   <p:clrMapOvr>

</xml_diff>

<commit_message>
10-minute deck: question and strategies on slide 2, Terra labels, Dogecoin/XRP and FTX markers on charts, fuller speaker notes, slides-with-notes PDF
</commit_message>
<xml_diff>
--- a/slides/presentation_10min.pptx
+++ b/slides/presentation_10min.pptx
@@ -516,7 +516,7 @@
           </a:p>
           <a:p>
             <a:r>
-              <a:t>• Good morning. Our project asks one question: do carry trades crash when they are crowded?</a:t>
+              <a:t>• Our project asks one question: do carry trades crash when they are crowded?</a:t>
             </a:r>
           </a:p>
           <a:p>
@@ -606,7 +606,7 @@
           </a:p>
           <a:p>
             <a:r>
-              <a:t>• To conclude: in both markets carry looks like compensation for crash risk.</a:t>
+              <a:t>• In both markets, carry looks like compensation for crash risk.</a:t>
             </a:r>
           </a:p>
           <a:p>
@@ -627,11 +627,6 @@
           <a:p>
             <a:r>
               <a:t>• The main limitations are a short crypto sample, few crowded FX months, and simple cost estimates.</a:t>
-            </a:r>
-          </a:p>
-          <a:p>
-            <a:r>
-              <a:t>• Thank you, we are happy to take questions.</a:t>
             </a:r>
           </a:p>
         </p:txBody>
@@ -749,6 +744,31 @@
               <a:t>• We wrote the hypotheses and all parameters down before running any backtest.</a:t>
             </a:r>
           </a:p>
+          <a:p>
+            <a:r>
+              <a:t>• Uncovered interest parity (UIP) says a high-rate currency should fall by exactly the rate gap, so carry would earn zero; in practice high-rate currencies tend not to fall that much, which is the forward premium puzzle.</a:t>
+            </a:r>
+          </a:p>
+          <a:p>
+            <a:r>
+              <a:t>• 'Up the stairs and down the elevator' means carry earns small steady gains most of the time and then loses a lot in a few weeks, so its returns have negative skew.</a:t>
+            </a:r>
+          </a:p>
+          <a:p>
+            <a:r>
+              <a:t>• Crowding matters because when many speculators hold the same trade, a shock forces them all to unwind together, which makes the crash larger.</a:t>
+            </a:r>
+          </a:p>
+          <a:p>
+            <a:r>
+              <a:t>• Hypothesis A says three things: carry earns a premium, crowded months are followed by weaker carry, and carry loses when volatility spikes.</a:t>
+            </a:r>
+          </a:p>
+          <a:p>
+            <a:r>
+              <a:t>• Hypothesis C says crypto funding carry earns a premium with little exposure to Bitcoin, and that its crashes come from single coins.</a:t>
+            </a:r>
+          </a:p>
         </p:txBody>
       </p:sp>
       <p:sp>
@@ -839,6 +859,31 @@
               <a:t>• Returns are net of costs, there is no look-ahead, and we keep the two coins that died, Terra (LUNA) and FTX Token (FTT).</a:t>
             </a:r>
           </a:p>
+          <a:p>
+            <a:r>
+              <a:t>• Out-of-sample means the later years that we did not look at while designing the strategy; if a rule still works there, it is less likely to be a result of data mining.</a:t>
+            </a:r>
+          </a:p>
+          <a:p>
+            <a:r>
+              <a:t>• Look-ahead bias means using information that was not public at the time of the trade; we avoid it because weights set at t earn the return of t+1, and CFTC positions measured on Tuesday are used only after their Friday release.</a:t>
+            </a:r>
+          </a:p>
+          <a:p>
+            <a:r>
+              <a:t>• Survivorship bias means testing only on assets that still exist today; we avoid it by keeping Terra and FTX Token, which together cost the crypto strategy about 100 percentage points of P&amp;L.</a:t>
+            </a:r>
+          </a:p>
+          <a:p>
+            <a:r>
+              <a:t>• A basis point (bp) is 0.01%, so a cost of 3 bp means we lose 0.03% of every dollar we trade.</a:t>
+            </a:r>
+          </a:p>
+          <a:p>
+            <a:r>
+              <a:t>• The Lustig–Roussanov–Verdelhan (LRV) factor is the published academic carry factor, built by buying high-rate and selling low-rate currency portfolios; we use it only to check our own carry series.</a:t>
+            </a:r>
+          </a:p>
         </p:txBody>
       </p:sp>
       <p:sp>
@@ -1234,6 +1279,31 @@
               <a:t>• The worst week was the Terra (LUNA) collapse in May 2022, -27.3%: traders were shorting Terra, its funding turned negative, and so our rule held it long.</a:t>
             </a:r>
           </a:p>
+          <a:p>
+            <a:r>
+              <a:t>• A perpetual future has no expiry date, so the exchange uses the funding payment to keep its price close to the spot price.</a:t>
+            </a:r>
+          </a:p>
+          <a:p>
+            <a:r>
+              <a:t>• For example, if funding is +0.01% every 8 hours, longs pay shorts about 0.03% a day, which is roughly 11% a year.</a:t>
+            </a:r>
+          </a:p>
+          <a:p>
+            <a:r>
+              <a:t>• So shorting a coin with high funding earns that payment, just as selling a low-rate currency and buying a high-rate one earns the interest gap in FX.</a:t>
+            </a:r>
+          </a:p>
+          <a:p>
+            <a:r>
+              <a:t>• The book is dollar-neutral, which means the long and short sides have the same size, so a move of the whole crypto market should roughly cancel out.</a:t>
+            </a:r>
+          </a:p>
+          <a:p>
+            <a:r>
+              <a:t>• The out-of-sample Sharpe since 2024 is strong, but it comes from less than three years of data, so we treat it with caution.</a:t>
+            </a:r>
+          </a:p>
         </p:txBody>
       </p:sp>
       <p:sp>
@@ -1339,6 +1409,31 @@
               <a:t>• Our takeaway is that crypto carry crashes in the mirror image of FX: it ends up long whatever traders short hardest.</a:t>
             </a:r>
           </a:p>
+          <a:p>
+            <a:r>
+              <a:t>• The table adds up: over the full sample, funding of +8.5%, price of -2.2% and costs of -2.2% give a net return of +4.1% a year.</a:t>
+            </a:r>
+          </a:p>
+          <a:p>
+            <a:r>
+              <a:t>• In 2020 to 2023 funding paid 12.3% a year, but price moves took away 12.5%, so the strategy lost money.</a:t>
+            </a:r>
+          </a:p>
+          <a:p>
+            <a:r>
+              <a:t>• Since 2024 funding paid only 3.1%, and price moves added 13.0%, which is luck rather than carry.</a:t>
+            </a:r>
+          </a:p>
+          <a:p>
+            <a:r>
+              <a:t>• The risk control capped each coin at one sixth of its side of the book and refused to buy coins with 7-day funding below minus 50% a year.</a:t>
+            </a:r>
+          </a:p>
+          <a:p>
+            <a:r>
+              <a:t>• It failed because the cap left part of the book in cash and halved the funding income, and on the Sunday before Terra collapsed its 7-day funding was only about minus 20% a year, so the filter did not remove it.</a:t>
+            </a:r>
+          </a:p>
         </p:txBody>
       </p:sp>
       <p:sp>
@@ -1432,6 +1527,31 @@
           <a:p>
             <a:r>
               <a:t>• Our takeaway is that the benefit of combining them is lower risk, not a higher return.</a:t>
+            </a:r>
+          </a:p>
+          <a:p>
+            <a:r>
+              <a:t>• We scale each strategy to 10% volatility so that neither one dominates the mix just because it is more volatile; crypto carry is about three times as volatile as FX carry before scaling.</a:t>
+            </a:r>
+          </a:p>
+          <a:p>
+            <a:r>
+              <a:t>• The scaling uses past volatility only, so there is no look-ahead in the combined portfolio.</a:t>
+            </a:r>
+          </a:p>
+          <a:p>
+            <a:r>
+              <a:t>• A correlation of 0.11 is close to zero, which means a bad month in one strategy says very little about the other.</a:t>
+            </a:r>
+          </a:p>
+          <a:p>
+            <a:r>
+              <a:t>• The window starts in 2021 because that is when both strategies have enough history for the volatility estimate.</a:t>
+            </a:r>
+          </a:p>
+          <a:p>
+            <a:r>
+              <a:t>• With only 67 months of overlap, these combined numbers are indicative rather than precise.</a:t>
             </a:r>
           </a:p>
         </p:txBody>
@@ -5134,7 +5254,7 @@
                 </a:solidFill>
                 <a:latin typeface="Calibri"/>
               </a:rPr>
-              <a:t>Same economic mechanism, two very different markets</a:t>
+              <a:t>Our question: do carry trades crash when they are crowded?</a:t>
             </a:r>
           </a:p>
         </p:txBody>
@@ -5147,8 +5267,8 @@
         </p:nvSpPr>
         <p:spPr>
           <a:xfrm>
-            <a:off x="548640" y="1828800"/>
-            <a:ext cx="5120640" cy="4206240"/>
+            <a:off x="548640" y="1691640"/>
+            <a:ext cx="5120640" cy="4937760"/>
           </a:xfrm>
           <a:prstGeom prst="rect">
             <a:avLst/>
@@ -5163,97 +5283,145 @@
           <a:p>
             <a:pPr algn="l">
               <a:spcAft>
-                <a:spcPts val="1200"/>
+                <a:spcPts val="700"/>
               </a:spcAft>
             </a:pPr>
             <a:r>
-              <a:rPr sz="1700" b="0" i="0">
+              <a:rPr sz="1400" b="0" i="0">
                 <a:solidFill>
                   <a:srgbClr val="1B1F27"/>
                 </a:solidFill>
                 <a:latin typeface="Calibri"/>
               </a:rPr>
-              <a:t>•  Carry: borrow the low-yield asset, hold the high-yield one.</a:t>
+              <a:t>•  We test it in two markets with the same economics: G10 currencies and crypto.</a:t>
             </a:r>
           </a:p>
           <a:p>
             <a:pPr algn="l">
               <a:spcAft>
-                <a:spcPts val="1200"/>
+                <a:spcPts val="700"/>
               </a:spcAft>
             </a:pPr>
             <a:r>
-              <a:rPr sz="1700" b="0" i="0">
+              <a:rPr sz="1400" b="0" i="0">
                 <a:solidFill>
                   <a:srgbClr val="1B1F27"/>
                 </a:solidFill>
                 <a:latin typeface="Calibri"/>
               </a:rPr>
-              <a:t>•  UIP says this earns nothing; in the data it earns a premium, with rare large crashes.</a:t>
+              <a:t>•  Strategy A is carry in seven G10 currencies against the US dollar, with a crowding filter built from CFTC data.</a:t>
             </a:r>
           </a:p>
           <a:p>
             <a:pPr algn="l">
               <a:spcAft>
-                <a:spcPts val="1200"/>
+                <a:spcPts val="700"/>
               </a:spcAft>
             </a:pPr>
             <a:r>
-              <a:rPr sz="1700" b="0" i="0">
+              <a:rPr sz="1400" b="0" i="0">
                 <a:solidFill>
                   <a:srgbClr val="1B1F27"/>
                 </a:solidFill>
                 <a:latin typeface="Calibri"/>
               </a:rPr>
-              <a:t>•  Crashes are worst when the trade is crowded and everyone unwinds at once (Brunnermeier, Nagel &amp; Pedersen 2008).</a:t>
+              <a:t>•  Strategy C is funding carry in twelve crypto perpetual futures on Binance, including the coins that collapsed, Terra and FTX Token.</a:t>
             </a:r>
           </a:p>
           <a:p>
             <a:pPr algn="l">
               <a:spcAft>
-                <a:spcPts val="1200"/>
+                <a:spcPts val="700"/>
               </a:spcAft>
             </a:pPr>
             <a:r>
-              <a:rPr sz="1700" b="1" i="0">
+              <a:rPr sz="1400" b="1" i="0">
                 <a:solidFill>
                   <a:srgbClr val="14213D"/>
                 </a:solidFill>
                 <a:latin typeface="Calibri"/>
               </a:rPr>
-              <a:t>Hypotheses, fixed before testing:</a:t>
+              <a:t>Why carry crashes</a:t>
             </a:r>
           </a:p>
           <a:p>
             <a:pPr algn="l">
               <a:spcAft>
-                <a:spcPts val="1200"/>
+                <a:spcPts val="700"/>
               </a:spcAft>
             </a:pPr>
             <a:r>
-              <a:rPr sz="1500" b="0" i="0">
+              <a:rPr sz="1400" b="0" i="0">
                 <a:solidFill>
                   <a:srgbClr val="1B1F27"/>
                 </a:solidFill>
                 <a:latin typeface="Calibri"/>
               </a:rPr>
-              <a:t>•  A: carry earns a premium; crowded months are followed by weaker carry; it loses in volatility spikes.</a:t>
+              <a:t>•  Carry borrows the low-yield asset and holds the high-yield one. UIP says this earns nothing, but in the data it earns a premium, with rare large crashes.</a:t>
             </a:r>
           </a:p>
           <a:p>
             <a:pPr algn="l">
               <a:spcAft>
-                <a:spcPts val="1200"/>
+                <a:spcPts val="700"/>
               </a:spcAft>
             </a:pPr>
             <a:r>
-              <a:rPr sz="1500" b="0" i="0">
+              <a:rPr sz="1400" b="0" i="0">
                 <a:solidFill>
                   <a:srgbClr val="1B1F27"/>
                 </a:solidFill>
                 <a:latin typeface="Calibri"/>
               </a:rPr>
-              <a:t>•  C: funding carry earns a premium with little BTC exposure; its crashes are coin-specific.</a:t>
+              <a:t>•  Crashes are worst when the trade is crowded and everyone unwinds at once (Brunnermeier, Nagel &amp; Pedersen 2008).</a:t>
+            </a:r>
+          </a:p>
+          <a:p>
+            <a:pPr algn="l">
+              <a:spcAft>
+                <a:spcPts val="700"/>
+              </a:spcAft>
+            </a:pPr>
+            <a:r>
+              <a:rPr sz="1400" b="1" i="0">
+                <a:solidFill>
+                  <a:srgbClr val="14213D"/>
+                </a:solidFill>
+                <a:latin typeface="Calibri"/>
+              </a:rPr>
+              <a:t>Hypotheses, fixed before testing</a:t>
+            </a:r>
+          </a:p>
+          <a:p>
+            <a:pPr algn="l">
+              <a:spcAft>
+                <a:spcPts val="700"/>
+              </a:spcAft>
+            </a:pPr>
+            <a:r>
+              <a:rPr sz="1400" b="0" i="0">
+                <a:solidFill>
+                  <a:srgbClr val="1B1F27"/>
+                </a:solidFill>
+                <a:latin typeface="Calibri"/>
+              </a:rPr>
+              <a:t>•  A: carry earns a premium, crowded months are followed by weaker carry, and it loses in volatility spikes.</a:t>
+            </a:r>
+          </a:p>
+          <a:p>
+            <a:pPr algn="l">
+              <a:spcAft>
+                <a:spcPts val="700"/>
+              </a:spcAft>
+            </a:pPr>
+            <a:r>
+              <a:rPr sz="1400" b="0" i="0">
+                <a:solidFill>
+                  <a:srgbClr val="1B1F27"/>
+                </a:solidFill>
+                <a:latin typeface="Calibri"/>
+              </a:rPr>
+              <a:t>•  C: funding carry earns a premium with little BTC exposure, and its crashes are coin-specific.</a:t>
             </a:r>
           </a:p>
         </p:txBody>
@@ -8924,14 +9092,14 @@
                 </a:solidFill>
                 <a:latin typeface="Calibri"/>
               </a:rPr>
-              <a:t>Binance perpetuals on BTC, ETH, BNB, XRP, ADA, DOGE, SOL, LTC, LINK, AVAX, LUNA, FTT; weekly, 2020–2026</a:t>
+              <a:t>Binance perpetuals on BTC, ETH, BNB, XRP, ADA, DOGE, SOL, LTC, LINK, AVAX, LUNA (Terra), FTT; weekly, 2020–2026</a:t>
             </a:r>
           </a:p>
         </p:txBody>
       </p:sp>
       <p:pic>
         <p:nvPicPr>
-          <p:cNvPr id="4" name="Picture 3" descr="c_cum.png"/>
+          <p:cNvPr id="4" name="Picture 3" descr="c_cum_marked.png"/>
           <p:cNvPicPr>
             <a:picLocks noChangeAspect="1"/>
           </p:cNvPicPr>
@@ -9391,7 +9559,7 @@
                 </a:solidFill>
                 <a:latin typeface="Calibri"/>
               </a:rPr>
-              <a:t>Worst week: LUNA collapse, May 2022</a:t>
+              <a:t>Worst week: LUNA (Terra) collapse, May 2022</a:t>
             </a:r>
           </a:p>
         </p:txBody>
@@ -9502,7 +9670,7 @@
       </p:sp>
       <p:pic>
         <p:nvPicPr>
-          <p:cNvPr id="4" name="Picture 3" descr="c_decomp.png"/>
+          <p:cNvPr id="4" name="Picture 3" descr="c_decomp_marked.png"/>
           <p:cNvPicPr>
             <a:picLocks noChangeAspect="1"/>
           </p:cNvPicPr>

</xml_diff>

<commit_message>
10-minute deck: performance boxes for A and C, hypothesis verdict table, robustness and originality on slides
</commit_message>
<xml_diff>
--- a/slides/presentation_10min.pptx
+++ b/slides/presentation_10min.pptx
@@ -606,6 +606,11 @@
           </a:p>
           <a:p>
             <a:r>
+              <a:t>• The table sums up our hypotheses: four are supported, crowding in FX leans yes, crypto funding carry is mixed, and our pre-set risk control did not work.</a:t>
+            </a:r>
+          </a:p>
+          <a:p>
+            <a:r>
               <a:t>• In both markets, carry looks like compensation for crash risk.</a:t>
             </a:r>
           </a:p>
@@ -622,6 +627,11 @@
           <a:p>
             <a:r>
               <a:t>• Because the two crash at different times, they diversify each other.</a:t>
+            </a:r>
+          </a:p>
+          <a:p>
+            <a:r>
+              <a:t>• What is new in our work is using CFTC positioning as a crowding filter on carry, and treating crypto funding as both the crypto interest-rate gap and a crowding signal, tested with the coins that died.</a:t>
             </a:r>
           </a:p>
           <a:p>
@@ -1056,7 +1066,7 @@
           </a:p>
           <a:p>
             <a:r>
-              <a:t>• Plain carry earns about 3.3% a year after costs, a net Sharpe of 0.37.</a:t>
+              <a:t>• Plain carry earns about 3.3% a year after costs with 8.9% volatility, a net Sharpe of 0.37.</a:t>
             </a:r>
           </a:p>
           <a:p>
@@ -1276,6 +1286,11 @@
           </a:p>
           <a:p>
             <a:r>
+              <a:t>• After costs it earns 4.1% a year with 30% volatility, and its maximum drawdown is -67%, much deeper than FX carry.</a:t>
+            </a:r>
+          </a:p>
+          <a:p>
+            <a:r>
               <a:t>• The worst week was the Terra (LUNA) collapse in May 2022, -27.3%: traders were shorting Terra, its funding turned negative, and so our rule held it long.</a:t>
             </a:r>
           </a:p>
@@ -1407,6 +1422,11 @@
           <a:p>
             <a:r>
               <a:t>• Our takeaway is that crypto carry crashes in the mirror image of FX: it ends up long whatever traders short hardest.</a:t>
+            </a:r>
+          </a:p>
+          <a:p>
+            <a:r>
+              <a:t>• As a robustness check we tried 6 lookback and rebalancing settings; all have a positive out-of-sample Sharpe, and the setting we fixed in advance is in the bottom half, so we did not pick the best one after the fact.</a:t>
             </a:r>
           </a:p>
           <a:p>
@@ -4911,8 +4931,8 @@
         </p:nvSpPr>
         <p:spPr>
           <a:xfrm>
-            <a:off x="548640" y="1554480"/>
-            <a:ext cx="5394960" cy="457200"/>
+            <a:off x="548640" y="1325880"/>
+            <a:ext cx="6766560" cy="457200"/>
           </a:xfrm>
           <a:prstGeom prst="rect">
             <a:avLst/>
@@ -4931,104 +4951,612 @@
               </a:spcAft>
             </a:pPr>
             <a:r>
-              <a:rPr sz="2000" b="1" i="0">
+              <a:rPr sz="1800" b="1" i="0">
                 <a:solidFill>
                   <a:srgbClr val="E39B17"/>
                 </a:solidFill>
                 <a:latin typeface="Calibri"/>
               </a:rPr>
-              <a:t>What we found</a:t>
-            </a:r>
-          </a:p>
-        </p:txBody>
-      </p:sp>
-      <p:sp>
-        <p:nvSpPr>
-          <p:cNvPr id="4" name="TextBox 3"/>
-          <p:cNvSpPr txBox="1"/>
-          <p:nvPr/>
-        </p:nvSpPr>
-        <p:spPr>
-          <a:xfrm>
-            <a:off x="548640" y="2103120"/>
-            <a:ext cx="5394960" cy="4114800"/>
-          </a:xfrm>
-          <a:prstGeom prst="rect">
-            <a:avLst/>
-          </a:prstGeom>
-          <a:noFill/>
-        </p:spPr>
-        <p:txBody>
-          <a:bodyPr wrap="square" anchor="t" lIns="0" rIns="0" tIns="0" bIns="0">
-            <a:spAutoFit/>
-          </a:bodyPr>
-          <a:lstStyle/>
-          <a:p>
-            <a:pPr algn="l">
-              <a:spcAft>
-                <a:spcPts val="1200"/>
-              </a:spcAft>
-            </a:pPr>
-            <a:r>
-              <a:rPr sz="1500" b="0" i="0">
-                <a:solidFill>
-                  <a:srgbClr val="FFFFFF"/>
-                </a:solidFill>
-                <a:latin typeface="Calibri"/>
-              </a:rPr>
-              <a:t>•  FX carry reproduces the academic factor (corr 0.82) and is exposed to volatility shocks.</a:t>
-            </a:r>
-          </a:p>
-          <a:p>
-            <a:pPr algn="l">
-              <a:spcAft>
-                <a:spcPts val="1200"/>
-              </a:spcAft>
-            </a:pPr>
-            <a:r>
-              <a:rPr sz="1500" b="0" i="0">
-                <a:solidFill>
-                  <a:srgbClr val="FFFFFF"/>
-                </a:solidFill>
-                <a:latin typeface="Calibri"/>
-              </a:rPr>
-              <a:t>•  Crowding predicts weaker carry, and the filter modestly improves the out-of-sample Sharpe.</a:t>
-            </a:r>
-          </a:p>
-          <a:p>
-            <a:pPr algn="l">
-              <a:spcAft>
-                <a:spcPts val="1200"/>
-              </a:spcAft>
-            </a:pPr>
-            <a:r>
-              <a:rPr sz="1500" b="0" i="0">
-                <a:solidFill>
-                  <a:srgbClr val="FFFFFF"/>
-                </a:solidFill>
-                <a:latin typeface="Calibri"/>
-              </a:rPr>
-              <a:t>•  Crypto funding carry is market-neutral, but its crashes are coin-specific: it ends up long what traders short hardest.</a:t>
-            </a:r>
-          </a:p>
-          <a:p>
-            <a:pPr algn="l">
-              <a:spcAft>
-                <a:spcPts val="1200"/>
-              </a:spcAft>
-            </a:pPr>
-            <a:r>
-              <a:rPr sz="1500" b="0" i="0">
-                <a:solidFill>
-                  <a:srgbClr val="FFFFFF"/>
-                </a:solidFill>
-                <a:latin typeface="Calibri"/>
-              </a:rPr>
-              <a:t>•  FX and crypto carry are nearly uncorrelated (0.11).</a:t>
-            </a:r>
-          </a:p>
-        </p:txBody>
-      </p:sp>
+              <a:t>Hypotheses: verdict and evidence</a:t>
+            </a:r>
+          </a:p>
+        </p:txBody>
+      </p:sp>
+      <p:graphicFrame>
+        <p:nvGraphicFramePr>
+          <p:cNvPr id="4" name="Table 3"/>
+          <p:cNvGraphicFramePr>
+            <a:graphicFrameLocks noGrp="1"/>
+          </p:cNvGraphicFramePr>
+          <p:nvPr/>
+        </p:nvGraphicFramePr>
+        <p:xfrm>
+          <a:off x="548640" y="1828800"/>
+          <a:ext cx="6949440" cy="3657600"/>
+        </p:xfrm>
+        <a:graphic>
+          <a:graphicData uri="http://schemas.openxmlformats.org/drawingml/2006/table">
+            <a:tbl>
+              <a:tblPr firstRow="1" bandRow="1">
+                <a:tableStyleId>{5C22544A-7EE6-4342-B048-85BDC9FD1C3A}</a:tableStyleId>
+              </a:tblPr>
+              <a:tblGrid>
+                <a:gridCol w="2514600"/>
+                <a:gridCol w="1143000"/>
+                <a:gridCol w="3291840"/>
+              </a:tblGrid>
+              <a:tr h="457200">
+                <a:tc>
+                  <a:txBody>
+                    <a:bodyPr/>
+                    <a:lstStyle/>
+                    <a:p>
+                      <a:pPr algn="l"/>
+                      <a:r>
+                        <a:rPr sz="1100" b="1">
+                          <a:solidFill>
+                            <a:srgbClr val="FFFFFF"/>
+                          </a:solidFill>
+                          <a:latin typeface="Calibri"/>
+                        </a:rPr>
+                        <a:t>Hypothesis</a:t>
+                      </a:r>
+                    </a:p>
+                  </a:txBody>
+                  <a:tcPr marL="73152" marR="73152">
+                    <a:solidFill>
+                      <a:srgbClr val="14213D"/>
+                    </a:solidFill>
+                  </a:tcPr>
+                </a:tc>
+                <a:tc>
+                  <a:txBody>
+                    <a:bodyPr/>
+                    <a:lstStyle/>
+                    <a:p>
+                      <a:pPr algn="l"/>
+                      <a:r>
+                        <a:rPr sz="1100" b="1">
+                          <a:solidFill>
+                            <a:srgbClr val="FFFFFF"/>
+                          </a:solidFill>
+                          <a:latin typeface="Calibri"/>
+                        </a:rPr>
+                        <a:t>Verdict</a:t>
+                      </a:r>
+                    </a:p>
+                  </a:txBody>
+                  <a:tcPr marL="73152" marR="73152">
+                    <a:solidFill>
+                      <a:srgbClr val="14213D"/>
+                    </a:solidFill>
+                  </a:tcPr>
+                </a:tc>
+                <a:tc>
+                  <a:txBody>
+                    <a:bodyPr/>
+                    <a:lstStyle/>
+                    <a:p>
+                      <a:pPr algn="l"/>
+                      <a:r>
+                        <a:rPr sz="1100" b="1">
+                          <a:solidFill>
+                            <a:srgbClr val="FFFFFF"/>
+                          </a:solidFill>
+                          <a:latin typeface="Calibri"/>
+                        </a:rPr>
+                        <a:t>Evidence</a:t>
+                      </a:r>
+                    </a:p>
+                  </a:txBody>
+                  <a:tcPr marL="73152" marR="73152">
+                    <a:solidFill>
+                      <a:srgbClr val="14213D"/>
+                    </a:solidFill>
+                  </a:tcPr>
+                </a:tc>
+              </a:tr>
+              <a:tr h="457200">
+                <a:tc>
+                  <a:txBody>
+                    <a:bodyPr/>
+                    <a:lstStyle/>
+                    <a:p>
+                      <a:pPr algn="l"/>
+                      <a:r>
+                        <a:rPr sz="1100" b="0">
+                          <a:solidFill>
+                            <a:srgbClr val="1B1F27"/>
+                          </a:solidFill>
+                          <a:latin typeface="Calibri"/>
+                        </a:rPr>
+                        <a:t>A1: G10 carry earns a premium</a:t>
+                      </a:r>
+                    </a:p>
+                  </a:txBody>
+                  <a:tcPr marL="73152" marR="73152">
+                    <a:solidFill>
+                      <a:srgbClr val="FFFFFF"/>
+                    </a:solidFill>
+                  </a:tcPr>
+                </a:tc>
+                <a:tc>
+                  <a:txBody>
+                    <a:bodyPr/>
+                    <a:lstStyle/>
+                    <a:p>
+                      <a:pPr algn="l"/>
+                      <a:r>
+                        <a:rPr sz="1100" b="1">
+                          <a:solidFill>
+                            <a:srgbClr val="2E7D4F"/>
+                          </a:solidFill>
+                          <a:latin typeface="Calibri"/>
+                        </a:rPr>
+                        <a:t>Supported</a:t>
+                      </a:r>
+                    </a:p>
+                  </a:txBody>
+                  <a:tcPr marL="73152" marR="73152">
+                    <a:solidFill>
+                      <a:srgbClr val="FFFFFF"/>
+                    </a:solidFill>
+                  </a:tcPr>
+                </a:tc>
+                <a:tc>
+                  <a:txBody>
+                    <a:bodyPr/>
+                    <a:lstStyle/>
+                    <a:p>
+                      <a:pPr algn="l"/>
+                      <a:r>
+                        <a:rPr sz="1100" b="0">
+                          <a:solidFill>
+                            <a:srgbClr val="1B1F27"/>
+                          </a:solidFill>
+                          <a:latin typeface="Calibri"/>
+                        </a:rPr>
+                        <a:t>Net Sharpe 0.37; 0.82 correlation with LRV</a:t>
+                      </a:r>
+                    </a:p>
+                  </a:txBody>
+                  <a:tcPr marL="73152" marR="73152">
+                    <a:solidFill>
+                      <a:srgbClr val="FFFFFF"/>
+                    </a:solidFill>
+                  </a:tcPr>
+                </a:tc>
+              </a:tr>
+              <a:tr h="457200">
+                <a:tc>
+                  <a:txBody>
+                    <a:bodyPr/>
+                    <a:lstStyle/>
+                    <a:p>
+                      <a:pPr algn="l"/>
+                      <a:r>
+                        <a:rPr sz="1100" b="0">
+                          <a:solidFill>
+                            <a:srgbClr val="1B1F27"/>
+                          </a:solidFill>
+                          <a:latin typeface="Calibri"/>
+                        </a:rPr>
+                        <a:t>A2: crowding predicts weaker carry</a:t>
+                      </a:r>
+                    </a:p>
+                  </a:txBody>
+                  <a:tcPr marL="73152" marR="73152">
+                    <a:solidFill>
+                      <a:srgbClr val="EEF1F6"/>
+                    </a:solidFill>
+                  </a:tcPr>
+                </a:tc>
+                <a:tc>
+                  <a:txBody>
+                    <a:bodyPr/>
+                    <a:lstStyle/>
+                    <a:p>
+                      <a:pPr algn="l"/>
+                      <a:r>
+                        <a:rPr sz="1100" b="1">
+                          <a:solidFill>
+                            <a:srgbClr val="B7700C"/>
+                          </a:solidFill>
+                          <a:latin typeface="Calibri"/>
+                        </a:rPr>
+                        <a:t>Leaning yes</a:t>
+                      </a:r>
+                    </a:p>
+                  </a:txBody>
+                  <a:tcPr marL="73152" marR="73152">
+                    <a:solidFill>
+                      <a:srgbClr val="EEF1F6"/>
+                    </a:solidFill>
+                  </a:tcPr>
+                </a:tc>
+                <a:tc>
+                  <a:txBody>
+                    <a:bodyPr/>
+                    <a:lstStyle/>
+                    <a:p>
+                      <a:pPr algn="l"/>
+                      <a:r>
+                        <a:rPr sz="1100" b="0">
+                          <a:solidFill>
+                            <a:srgbClr val="1B1F27"/>
+                          </a:solidFill>
+                          <a:latin typeface="Calibri"/>
+                        </a:rPr>
+                        <a:t>0.02% vs 0.30% next month; OOS Sharpe 0.27 → 0.32; missed 2008</a:t>
+                      </a:r>
+                    </a:p>
+                  </a:txBody>
+                  <a:tcPr marL="73152" marR="73152">
+                    <a:solidFill>
+                      <a:srgbClr val="EEF1F6"/>
+                    </a:solidFill>
+                  </a:tcPr>
+                </a:tc>
+              </a:tr>
+              <a:tr h="457200">
+                <a:tc>
+                  <a:txBody>
+                    <a:bodyPr/>
+                    <a:lstStyle/>
+                    <a:p>
+                      <a:pPr algn="l"/>
+                      <a:r>
+                        <a:rPr sz="1100" b="0">
+                          <a:solidFill>
+                            <a:srgbClr val="1B1F27"/>
+                          </a:solidFill>
+                          <a:latin typeface="Calibri"/>
+                        </a:rPr>
+                        <a:t>A3: carry loses in volatility spikes</a:t>
+                      </a:r>
+                    </a:p>
+                  </a:txBody>
+                  <a:tcPr marL="73152" marR="73152">
+                    <a:solidFill>
+                      <a:srgbClr val="FFFFFF"/>
+                    </a:solidFill>
+                  </a:tcPr>
+                </a:tc>
+                <a:tc>
+                  <a:txBody>
+                    <a:bodyPr/>
+                    <a:lstStyle/>
+                    <a:p>
+                      <a:pPr algn="l"/>
+                      <a:r>
+                        <a:rPr sz="1100" b="1">
+                          <a:solidFill>
+                            <a:srgbClr val="2E7D4F"/>
+                          </a:solidFill>
+                          <a:latin typeface="Calibri"/>
+                        </a:rPr>
+                        <a:t>Supported</a:t>
+                      </a:r>
+                    </a:p>
+                  </a:txBody>
+                  <a:tcPr marL="73152" marR="73152">
+                    <a:solidFill>
+                      <a:srgbClr val="FFFFFF"/>
+                    </a:solidFill>
+                  </a:tcPr>
+                </a:tc>
+                <a:tc>
+                  <a:txBody>
+                    <a:bodyPr/>
+                    <a:lstStyle/>
+                    <a:p>
+                      <a:pPr algn="l"/>
+                      <a:r>
+                        <a:rPr sz="1100" b="0">
+                          <a:solidFill>
+                            <a:srgbClr val="1B1F27"/>
+                          </a:solidFill>
+                          <a:latin typeface="Calibri"/>
+                        </a:rPr>
+                        <a:t>Vol beta -1.55 (t = -3.7); alpha not significant</a:t>
+                      </a:r>
+                    </a:p>
+                  </a:txBody>
+                  <a:tcPr marL="73152" marR="73152">
+                    <a:solidFill>
+                      <a:srgbClr val="FFFFFF"/>
+                    </a:solidFill>
+                  </a:tcPr>
+                </a:tc>
+              </a:tr>
+              <a:tr h="457200">
+                <a:tc>
+                  <a:txBody>
+                    <a:bodyPr/>
+                    <a:lstStyle/>
+                    <a:p>
+                      <a:pPr algn="l"/>
+                      <a:r>
+                        <a:rPr sz="1100" b="0">
+                          <a:solidFill>
+                            <a:srgbClr val="1B1F27"/>
+                          </a:solidFill>
+                          <a:latin typeface="Calibri"/>
+                        </a:rPr>
+                        <a:t>C1: funding carry earns a premium</a:t>
+                      </a:r>
+                    </a:p>
+                  </a:txBody>
+                  <a:tcPr marL="73152" marR="73152">
+                    <a:solidFill>
+                      <a:srgbClr val="EEF1F6"/>
+                    </a:solidFill>
+                  </a:tcPr>
+                </a:tc>
+                <a:tc>
+                  <a:txBody>
+                    <a:bodyPr/>
+                    <a:lstStyle/>
+                    <a:p>
+                      <a:pPr algn="l"/>
+                      <a:r>
+                        <a:rPr sz="1100" b="1">
+                          <a:solidFill>
+                            <a:srgbClr val="B7700C"/>
+                          </a:solidFill>
+                          <a:latin typeface="Calibri"/>
+                        </a:rPr>
+                        <a:t>Mixed</a:t>
+                      </a:r>
+                    </a:p>
+                  </a:txBody>
+                  <a:tcPr marL="73152" marR="73152">
+                    <a:solidFill>
+                      <a:srgbClr val="EEF1F6"/>
+                    </a:solidFill>
+                  </a:tcPr>
+                </a:tc>
+                <a:tc>
+                  <a:txBody>
+                    <a:bodyPr/>
+                    <a:lstStyle/>
+                    <a:p>
+                      <a:pPr algn="l"/>
+                      <a:r>
+                        <a:rPr sz="1100" b="0">
+                          <a:solidFill>
+                            <a:srgbClr val="1B1F27"/>
+                          </a:solidFill>
+                          <a:latin typeface="Calibri"/>
+                        </a:rPr>
+                        <a:t>Funding +8.5% a year, but net Sharpe 0.14; price moves dominate</a:t>
+                      </a:r>
+                    </a:p>
+                  </a:txBody>
+                  <a:tcPr marL="73152" marR="73152">
+                    <a:solidFill>
+                      <a:srgbClr val="EEF1F6"/>
+                    </a:solidFill>
+                  </a:tcPr>
+                </a:tc>
+              </a:tr>
+              <a:tr h="457200">
+                <a:tc>
+                  <a:txBody>
+                    <a:bodyPr/>
+                    <a:lstStyle/>
+                    <a:p>
+                      <a:pPr algn="l"/>
+                      <a:r>
+                        <a:rPr sz="1100" b="0">
+                          <a:solidFill>
+                            <a:srgbClr val="1B1F27"/>
+                          </a:solidFill>
+                          <a:latin typeface="Calibri"/>
+                        </a:rPr>
+                        <a:t>C2: no BTC exposure; coin-specific crashes</a:t>
+                      </a:r>
+                    </a:p>
+                  </a:txBody>
+                  <a:tcPr marL="73152" marR="73152">
+                    <a:solidFill>
+                      <a:srgbClr val="FFFFFF"/>
+                    </a:solidFill>
+                  </a:tcPr>
+                </a:tc>
+                <a:tc>
+                  <a:txBody>
+                    <a:bodyPr/>
+                    <a:lstStyle/>
+                    <a:p>
+                      <a:pPr algn="l"/>
+                      <a:r>
+                        <a:rPr sz="1100" b="1">
+                          <a:solidFill>
+                            <a:srgbClr val="2E7D4F"/>
+                          </a:solidFill>
+                          <a:latin typeface="Calibri"/>
+                        </a:rPr>
+                        <a:t>Supported</a:t>
+                      </a:r>
+                    </a:p>
+                  </a:txBody>
+                  <a:tcPr marL="73152" marR="73152">
+                    <a:solidFill>
+                      <a:srgbClr val="FFFFFF"/>
+                    </a:solidFill>
+                  </a:tcPr>
+                </a:tc>
+                <a:tc>
+                  <a:txBody>
+                    <a:bodyPr/>
+                    <a:lstStyle/>
+                    <a:p>
+                      <a:pPr algn="l"/>
+                      <a:r>
+                        <a:rPr sz="1100" b="0">
+                          <a:solidFill>
+                            <a:srgbClr val="1B1F27"/>
+                          </a:solidFill>
+                          <a:latin typeface="Calibri"/>
+                        </a:rPr>
+                        <a:t>BTC beta ≈ 0; Terra -87 pts; worst week -27%</a:t>
+                      </a:r>
+                    </a:p>
+                  </a:txBody>
+                  <a:tcPr marL="73152" marR="73152">
+                    <a:solidFill>
+                      <a:srgbClr val="FFFFFF"/>
+                    </a:solidFill>
+                  </a:tcPr>
+                </a:tc>
+              </a:tr>
+              <a:tr h="457200">
+                <a:tc>
+                  <a:txBody>
+                    <a:bodyPr/>
+                    <a:lstStyle/>
+                    <a:p>
+                      <a:pPr algn="l"/>
+                      <a:r>
+                        <a:rPr sz="1100" b="0">
+                          <a:solidFill>
+                            <a:srgbClr val="1B1F27"/>
+                          </a:solidFill>
+                          <a:latin typeface="Calibri"/>
+                        </a:rPr>
+                        <a:t>Pre-set risk control helps</a:t>
+                      </a:r>
+                    </a:p>
+                  </a:txBody>
+                  <a:tcPr marL="73152" marR="73152">
+                    <a:solidFill>
+                      <a:srgbClr val="EEF1F6"/>
+                    </a:solidFill>
+                  </a:tcPr>
+                </a:tc>
+                <a:tc>
+                  <a:txBody>
+                    <a:bodyPr/>
+                    <a:lstStyle/>
+                    <a:p>
+                      <a:pPr algn="l"/>
+                      <a:r>
+                        <a:rPr sz="1100" b="1">
+                          <a:solidFill>
+                            <a:srgbClr val="B83227"/>
+                          </a:solidFill>
+                          <a:latin typeface="Calibri"/>
+                        </a:rPr>
+                        <a:t>Not supported</a:t>
+                      </a:r>
+                    </a:p>
+                  </a:txBody>
+                  <a:tcPr marL="73152" marR="73152">
+                    <a:solidFill>
+                      <a:srgbClr val="EEF1F6"/>
+                    </a:solidFill>
+                  </a:tcPr>
+                </a:tc>
+                <a:tc>
+                  <a:txBody>
+                    <a:bodyPr/>
+                    <a:lstStyle/>
+                    <a:p>
+                      <a:pPr algn="l"/>
+                      <a:r>
+                        <a:rPr sz="1100" b="0">
+                          <a:solidFill>
+                            <a:srgbClr val="1B1F27"/>
+                          </a:solidFill>
+                          <a:latin typeface="Calibri"/>
+                        </a:rPr>
+                        <a:t>Sharpe 0.14 → -0.16</a:t>
+                      </a:r>
+                    </a:p>
+                  </a:txBody>
+                  <a:tcPr marL="73152" marR="73152">
+                    <a:solidFill>
+                      <a:srgbClr val="EEF1F6"/>
+                    </a:solidFill>
+                  </a:tcPr>
+                </a:tc>
+              </a:tr>
+              <a:tr h="457200">
+                <a:tc>
+                  <a:txBody>
+                    <a:bodyPr/>
+                    <a:lstStyle/>
+                    <a:p>
+                      <a:pPr algn="l"/>
+                      <a:r>
+                        <a:rPr sz="1100" b="0">
+                          <a:solidFill>
+                            <a:srgbClr val="1B1F27"/>
+                          </a:solidFill>
+                          <a:latin typeface="Calibri"/>
+                        </a:rPr>
+                        <a:t>FX and crypto carry diversify</a:t>
+                      </a:r>
+                    </a:p>
+                  </a:txBody>
+                  <a:tcPr marL="73152" marR="73152">
+                    <a:solidFill>
+                      <a:srgbClr val="FFFFFF"/>
+                    </a:solidFill>
+                  </a:tcPr>
+                </a:tc>
+                <a:tc>
+                  <a:txBody>
+                    <a:bodyPr/>
+                    <a:lstStyle/>
+                    <a:p>
+                      <a:pPr algn="l"/>
+                      <a:r>
+                        <a:rPr sz="1100" b="1">
+                          <a:solidFill>
+                            <a:srgbClr val="2E7D4F"/>
+                          </a:solidFill>
+                          <a:latin typeface="Calibri"/>
+                        </a:rPr>
+                        <a:t>Supported</a:t>
+                      </a:r>
+                    </a:p>
+                  </a:txBody>
+                  <a:tcPr marL="73152" marR="73152">
+                    <a:solidFill>
+                      <a:srgbClr val="FFFFFF"/>
+                    </a:solidFill>
+                  </a:tcPr>
+                </a:tc>
+                <a:tc>
+                  <a:txBody>
+                    <a:bodyPr/>
+                    <a:lstStyle/>
+                    <a:p>
+                      <a:pPr algn="l"/>
+                      <a:r>
+                        <a:rPr sz="1100" b="0">
+                          <a:solidFill>
+                            <a:srgbClr val="1B1F27"/>
+                          </a:solidFill>
+                          <a:latin typeface="Calibri"/>
+                        </a:rPr>
+                        <a:t>Correlation 0.11; vol 7.0% vs about 9%</a:t>
+                      </a:r>
+                    </a:p>
+                  </a:txBody>
+                  <a:tcPr marL="73152" marR="73152">
+                    <a:solidFill>
+                      <a:srgbClr val="FFFFFF"/>
+                    </a:solidFill>
+                  </a:tcPr>
+                </a:tc>
+              </a:tr>
+            </a:tbl>
+          </a:graphicData>
+        </a:graphic>
+      </p:graphicFrame>
       <p:sp>
         <p:nvSpPr>
           <p:cNvPr id="5" name="TextBox 4"/>
@@ -5037,8 +5565,8 @@
         </p:nvSpPr>
         <p:spPr>
           <a:xfrm>
-            <a:off x="6400800" y="1554480"/>
-            <a:ext cx="5212080" cy="457200"/>
+            <a:off x="7863840" y="1325880"/>
+            <a:ext cx="3840480" cy="457200"/>
           </a:xfrm>
           <a:prstGeom prst="rect">
             <a:avLst/>
@@ -5057,13 +5585,13 @@
               </a:spcAft>
             </a:pPr>
             <a:r>
-              <a:rPr sz="2000" b="1" i="0">
+              <a:rPr sz="1800" b="1" i="0">
                 <a:solidFill>
                   <a:srgbClr val="E39B17"/>
                 </a:solidFill>
                 <a:latin typeface="Calibri"/>
               </a:rPr>
-              <a:t>Limitations</a:t>
+              <a:t>What is new</a:t>
             </a:r>
           </a:p>
         </p:txBody>
@@ -5076,8 +5604,8 @@
         </p:nvSpPr>
         <p:spPr>
           <a:xfrm>
-            <a:off x="6400800" y="2103120"/>
-            <a:ext cx="5212080" cy="4114800"/>
+            <a:off x="7863840" y="1783080"/>
+            <a:ext cx="3840480" cy="2011680"/>
           </a:xfrm>
           <a:prstGeom prst="rect">
             <a:avLst/>
@@ -5092,59 +5620,137 @@
           <a:p>
             <a:pPr algn="l">
               <a:spcAft>
-                <a:spcPts val="1200"/>
+                <a:spcPts val="800"/>
               </a:spcAft>
             </a:pPr>
             <a:r>
-              <a:rPr sz="1500" b="0" i="0">
+              <a:rPr sz="1300" b="0" i="0">
                 <a:solidFill>
                   <a:srgbClr val="FFFFFF"/>
                 </a:solidFill>
                 <a:latin typeface="Calibri"/>
               </a:rPr>
-              <a:t>•  The crypto history is short (2020–2026) and covers only 12 coins.</a:t>
+              <a:t>•  We use CFTC speculator positioning as a crowding filter on G10 carry.</a:t>
             </a:r>
           </a:p>
           <a:p>
             <a:pPr algn="l">
               <a:spcAft>
-                <a:spcPts val="1200"/>
+                <a:spcPts val="800"/>
               </a:spcAft>
             </a:pPr>
             <a:r>
-              <a:rPr sz="1500" b="0" i="0">
+              <a:rPr sz="1300" b="0" i="0">
                 <a:solidFill>
                   <a:srgbClr val="FFFFFF"/>
                 </a:solidFill>
                 <a:latin typeface="Calibri"/>
               </a:rPr>
-              <a:t>•  There are only 33 crowded FX months, and the 2008 crash was not flagged.</a:t>
-            </a:r>
-          </a:p>
+              <a:t>•  We treat crypto funding as the crypto interest-rate gap and as a crowding signal, and test it with the coins that died.</a:t>
+            </a:r>
+          </a:p>
+        </p:txBody>
+      </p:sp>
+      <p:sp>
+        <p:nvSpPr>
+          <p:cNvPr id="7" name="TextBox 6"/>
+          <p:cNvSpPr txBox="1"/>
+          <p:nvPr/>
+        </p:nvSpPr>
+        <p:spPr>
+          <a:xfrm>
+            <a:off x="7863840" y="3794760"/>
+            <a:ext cx="3840480" cy="457200"/>
+          </a:xfrm>
+          <a:prstGeom prst="rect">
+            <a:avLst/>
+          </a:prstGeom>
+          <a:noFill/>
+        </p:spPr>
+        <p:txBody>
+          <a:bodyPr wrap="square" anchor="t" lIns="0" rIns="0" tIns="0" bIns="0">
+            <a:spAutoFit/>
+          </a:bodyPr>
+          <a:lstStyle/>
           <a:p>
             <a:pPr algn="l">
               <a:spcAft>
-                <a:spcPts val="1200"/>
+                <a:spcPts val="600"/>
               </a:spcAft>
             </a:pPr>
             <a:r>
-              <a:rPr sz="1500" b="0" i="0">
-                <a:solidFill>
-                  <a:srgbClr val="FFFFFF"/>
+              <a:rPr sz="1800" b="1" i="0">
+                <a:solidFill>
+                  <a:srgbClr val="E39B17"/>
                 </a:solidFill>
                 <a:latin typeface="Calibri"/>
               </a:rPr>
-              <a:t>•  The crypto results depend on the lookback and the rebalancing frequency.</a:t>
-            </a:r>
-          </a:p>
+              <a:t>Limitations</a:t>
+            </a:r>
+          </a:p>
+        </p:txBody>
+      </p:sp>
+      <p:sp>
+        <p:nvSpPr>
+          <p:cNvPr id="8" name="TextBox 7"/>
+          <p:cNvSpPr txBox="1"/>
+          <p:nvPr/>
+        </p:nvSpPr>
+        <p:spPr>
+          <a:xfrm>
+            <a:off x="7863840" y="4251960"/>
+            <a:ext cx="3840480" cy="2377440"/>
+          </a:xfrm>
+          <a:prstGeom prst="rect">
+            <a:avLst/>
+          </a:prstGeom>
+          <a:noFill/>
+        </p:spPr>
+        <p:txBody>
+          <a:bodyPr wrap="square" anchor="t" lIns="0" rIns="0" tIns="0" bIns="0">
+            <a:spAutoFit/>
+          </a:bodyPr>
+          <a:lstStyle/>
           <a:p>
             <a:pPr algn="l">
               <a:spcAft>
-                <a:spcPts val="1200"/>
+                <a:spcPts val="800"/>
               </a:spcAft>
             </a:pPr>
             <a:r>
-              <a:rPr sz="1500" b="0" i="0">
+              <a:rPr sz="1300" b="0" i="0">
+                <a:solidFill>
+                  <a:srgbClr val="FFFFFF"/>
+                </a:solidFill>
+                <a:latin typeface="Calibri"/>
+              </a:rPr>
+              <a:t>•  The crypto history is short (2020–2026) and covers only 12 coins.</a:t>
+            </a:r>
+          </a:p>
+          <a:p>
+            <a:pPr algn="l">
+              <a:spcAft>
+                <a:spcPts val="800"/>
+              </a:spcAft>
+            </a:pPr>
+            <a:r>
+              <a:rPr sz="1300" b="0" i="0">
+                <a:solidFill>
+                  <a:srgbClr val="FFFFFF"/>
+                </a:solidFill>
+                <a:latin typeface="Calibri"/>
+              </a:rPr>
+              <a:t>•  There are only 33 crowded FX months, and the 2008 crash was not flagged.</a:t>
+            </a:r>
+          </a:p>
+          <a:p>
+            <a:pPr algn="l">
+              <a:spcAft>
+                <a:spcPts val="800"/>
+              </a:spcAft>
+            </a:pPr>
+            <a:r>
+              <a:rPr sz="1300" b="0" i="0">
                 <a:solidFill>
                   <a:srgbClr val="FFFFFF"/>
                 </a:solidFill>
@@ -8254,14 +8860,60 @@
       </p:sp>
       <p:sp>
         <p:nvSpPr>
-          <p:cNvPr id="13" name="TextBox 12"/>
+          <p:cNvPr id="13" name="Rounded Rectangle 12"/>
+          <p:cNvSpPr/>
+          <p:nvPr/>
+        </p:nvSpPr>
+        <p:spPr>
+          <a:xfrm>
+            <a:off x="548640" y="5349240"/>
+            <a:ext cx="7132320" cy="1188720"/>
+          </a:xfrm>
+          <a:prstGeom prst="roundRect">
+            <a:avLst>
+              <a:gd name="adj" fmla="val 8000"/>
+            </a:avLst>
+          </a:prstGeom>
+          <a:solidFill>
+            <a:srgbClr val="EEF1F6"/>
+          </a:solidFill>
+          <a:ln>
+            <a:noFill/>
+          </a:ln>
+          <a:effectLst/>
+        </p:spPr>
+        <p:style>
+          <a:lnRef idx="1">
+            <a:schemeClr val="accent1"/>
+          </a:lnRef>
+          <a:fillRef idx="3">
+            <a:schemeClr val="accent1"/>
+          </a:fillRef>
+          <a:effectRef idx="2">
+            <a:schemeClr val="accent1"/>
+          </a:effectRef>
+          <a:fontRef idx="minor">
+            <a:schemeClr val="lt1"/>
+          </a:fontRef>
+        </p:style>
+        <p:txBody>
+          <a:bodyPr rtlCol="0" anchor="ctr"/>
+          <a:lstStyle/>
+          <a:p>
+            <a:pPr algn="ctr"/>
+          </a:p>
+        </p:txBody>
+      </p:sp>
+      <p:sp>
+        <p:nvSpPr>
+          <p:cNvPr id="14" name="TextBox 13"/>
           <p:cNvSpPr txBox="1"/>
           <p:nvPr/>
         </p:nvSpPr>
         <p:spPr>
           <a:xfrm>
-            <a:off x="548640" y="5440680"/>
-            <a:ext cx="7132320" cy="822960"/>
+            <a:off x="777240" y="5440679"/>
+            <a:ext cx="6675120" cy="320040"/>
           </a:xfrm>
           <a:prstGeom prst="rect">
             <a:avLst/>
@@ -8280,13 +8932,247 @@
               </a:spcAft>
             </a:pPr>
             <a:r>
-              <a:rPr sz="1400" b="0" i="0">
+              <a:rPr sz="1300" b="1" i="0">
+                <a:solidFill>
+                  <a:srgbClr val="14213D"/>
+                </a:solidFill>
+                <a:latin typeface="Calibri"/>
+              </a:rPr>
+              <a:t>Full sample 1999–2026, net of costs: carry / crowd-filtered</a:t>
+            </a:r>
+          </a:p>
+        </p:txBody>
+      </p:sp>
+      <p:sp>
+        <p:nvSpPr>
+          <p:cNvPr id="15" name="TextBox 14"/>
+          <p:cNvSpPr txBox="1"/>
+          <p:nvPr/>
+        </p:nvSpPr>
+        <p:spPr>
+          <a:xfrm>
+            <a:off x="777240" y="5733288"/>
+            <a:ext cx="2133599" cy="411480"/>
+          </a:xfrm>
+          <a:prstGeom prst="rect">
+            <a:avLst/>
+          </a:prstGeom>
+          <a:noFill/>
+        </p:spPr>
+        <p:txBody>
+          <a:bodyPr wrap="square" anchor="t" lIns="0" rIns="0" tIns="0" bIns="0">
+            <a:spAutoFit/>
+          </a:bodyPr>
+          <a:lstStyle/>
+          <a:p>
+            <a:pPr algn="l">
+              <a:spcAft>
+                <a:spcPts val="600"/>
+              </a:spcAft>
+            </a:pPr>
+            <a:r>
+              <a:rPr sz="2000" b="1" i="0">
+                <a:solidFill>
+                  <a:srgbClr val="14213D"/>
+                </a:solidFill>
+                <a:latin typeface="Cambria"/>
+              </a:rPr>
+              <a:t>3.3% / 3.2%</a:t>
+            </a:r>
+          </a:p>
+        </p:txBody>
+      </p:sp>
+      <p:sp>
+        <p:nvSpPr>
+          <p:cNvPr id="16" name="TextBox 15"/>
+          <p:cNvSpPr txBox="1"/>
+          <p:nvPr/>
+        </p:nvSpPr>
+        <p:spPr>
+          <a:xfrm>
+            <a:off x="777240" y="6153912"/>
+            <a:ext cx="2133599" cy="274320"/>
+          </a:xfrm>
+          <a:prstGeom prst="rect">
+            <a:avLst/>
+          </a:prstGeom>
+          <a:noFill/>
+        </p:spPr>
+        <p:txBody>
+          <a:bodyPr wrap="square" anchor="t" lIns="0" rIns="0" tIns="0" bIns="0">
+            <a:spAutoFit/>
+          </a:bodyPr>
+          <a:lstStyle/>
+          <a:p>
+            <a:pPr algn="l">
+              <a:spcAft>
+                <a:spcPts val="600"/>
+              </a:spcAft>
+            </a:pPr>
+            <a:r>
+              <a:rPr sz="1100" b="0" i="0">
                 <a:solidFill>
                   <a:srgbClr val="5C677D"/>
                 </a:solidFill>
                 <a:latin typeface="Calibri"/>
               </a:rPr>
-              <a:t>Full sample, net: Sharpe 0.37 carry, 0.38 filtered; max drawdown -37% either way.</a:t>
+              <a:t>Net return a year</a:t>
+            </a:r>
+          </a:p>
+        </p:txBody>
+      </p:sp>
+      <p:sp>
+        <p:nvSpPr>
+          <p:cNvPr id="17" name="TextBox 16"/>
+          <p:cNvSpPr txBox="1"/>
+          <p:nvPr/>
+        </p:nvSpPr>
+        <p:spPr>
+          <a:xfrm>
+            <a:off x="3002280" y="5733288"/>
+            <a:ext cx="2133599" cy="411480"/>
+          </a:xfrm>
+          <a:prstGeom prst="rect">
+            <a:avLst/>
+          </a:prstGeom>
+          <a:noFill/>
+        </p:spPr>
+        <p:txBody>
+          <a:bodyPr wrap="square" anchor="t" lIns="0" rIns="0" tIns="0" bIns="0">
+            <a:spAutoFit/>
+          </a:bodyPr>
+          <a:lstStyle/>
+          <a:p>
+            <a:pPr algn="l">
+              <a:spcAft>
+                <a:spcPts val="600"/>
+              </a:spcAft>
+            </a:pPr>
+            <a:r>
+              <a:rPr sz="2000" b="1" i="0">
+                <a:solidFill>
+                  <a:srgbClr val="14213D"/>
+                </a:solidFill>
+                <a:latin typeface="Cambria"/>
+              </a:rPr>
+              <a:t>8.9% / 8.5%</a:t>
+            </a:r>
+          </a:p>
+        </p:txBody>
+      </p:sp>
+      <p:sp>
+        <p:nvSpPr>
+          <p:cNvPr id="18" name="TextBox 17"/>
+          <p:cNvSpPr txBox="1"/>
+          <p:nvPr/>
+        </p:nvSpPr>
+        <p:spPr>
+          <a:xfrm>
+            <a:off x="3002280" y="6153912"/>
+            <a:ext cx="2133599" cy="274320"/>
+          </a:xfrm>
+          <a:prstGeom prst="rect">
+            <a:avLst/>
+          </a:prstGeom>
+          <a:noFill/>
+        </p:spPr>
+        <p:txBody>
+          <a:bodyPr wrap="square" anchor="t" lIns="0" rIns="0" tIns="0" bIns="0">
+            <a:spAutoFit/>
+          </a:bodyPr>
+          <a:lstStyle/>
+          <a:p>
+            <a:pPr algn="l">
+              <a:spcAft>
+                <a:spcPts val="600"/>
+              </a:spcAft>
+            </a:pPr>
+            <a:r>
+              <a:rPr sz="1100" b="0" i="0">
+                <a:solidFill>
+                  <a:srgbClr val="5C677D"/>
+                </a:solidFill>
+                <a:latin typeface="Calibri"/>
+              </a:rPr>
+              <a:t>Volatility a year</a:t>
+            </a:r>
+          </a:p>
+        </p:txBody>
+      </p:sp>
+      <p:sp>
+        <p:nvSpPr>
+          <p:cNvPr id="19" name="TextBox 18"/>
+          <p:cNvSpPr txBox="1"/>
+          <p:nvPr/>
+        </p:nvSpPr>
+        <p:spPr>
+          <a:xfrm>
+            <a:off x="5227319" y="5733288"/>
+            <a:ext cx="2133599" cy="411480"/>
+          </a:xfrm>
+          <a:prstGeom prst="rect">
+            <a:avLst/>
+          </a:prstGeom>
+          <a:noFill/>
+        </p:spPr>
+        <p:txBody>
+          <a:bodyPr wrap="square" anchor="t" lIns="0" rIns="0" tIns="0" bIns="0">
+            <a:spAutoFit/>
+          </a:bodyPr>
+          <a:lstStyle/>
+          <a:p>
+            <a:pPr algn="l">
+              <a:spcAft>
+                <a:spcPts val="600"/>
+              </a:spcAft>
+            </a:pPr>
+            <a:r>
+              <a:rPr sz="2000" b="1" i="0">
+                <a:solidFill>
+                  <a:srgbClr val="B83227"/>
+                </a:solidFill>
+                <a:latin typeface="Cambria"/>
+              </a:rPr>
+              <a:t>-37% / -37%</a:t>
+            </a:r>
+          </a:p>
+        </p:txBody>
+      </p:sp>
+      <p:sp>
+        <p:nvSpPr>
+          <p:cNvPr id="20" name="TextBox 19"/>
+          <p:cNvSpPr txBox="1"/>
+          <p:nvPr/>
+        </p:nvSpPr>
+        <p:spPr>
+          <a:xfrm>
+            <a:off x="5227319" y="6153912"/>
+            <a:ext cx="2133599" cy="274320"/>
+          </a:xfrm>
+          <a:prstGeom prst="rect">
+            <a:avLst/>
+          </a:prstGeom>
+          <a:noFill/>
+        </p:spPr>
+        <p:txBody>
+          <a:bodyPr wrap="square" anchor="t" lIns="0" rIns="0" tIns="0" bIns="0">
+            <a:spAutoFit/>
+          </a:bodyPr>
+          <a:lstStyle/>
+          <a:p>
+            <a:pPr algn="l">
+              <a:spcAft>
+                <a:spcPts val="600"/>
+              </a:spcAft>
+            </a:pPr>
+            <a:r>
+              <a:rPr sz="1100" b="0" i="0">
+                <a:solidFill>
+                  <a:srgbClr val="5C677D"/>
+                </a:solidFill>
+                <a:latin typeface="Calibri"/>
+              </a:rPr>
+              <a:t>Max drawdown</a:t>
             </a:r>
           </a:p>
         </p:txBody>
@@ -9560,6 +10446,325 @@
                 <a:latin typeface="Calibri"/>
               </a:rPr>
               <a:t>Worst week: LUNA (Terra) collapse, May 2022</a:t>
+            </a:r>
+          </a:p>
+        </p:txBody>
+      </p:sp>
+      <p:sp>
+        <p:nvSpPr>
+          <p:cNvPr id="15" name="Rounded Rectangle 14"/>
+          <p:cNvSpPr/>
+          <p:nvPr/>
+        </p:nvSpPr>
+        <p:spPr>
+          <a:xfrm>
+            <a:off x="548640" y="5440680"/>
+            <a:ext cx="6949440" cy="1188720"/>
+          </a:xfrm>
+          <a:prstGeom prst="roundRect">
+            <a:avLst>
+              <a:gd name="adj" fmla="val 8000"/>
+            </a:avLst>
+          </a:prstGeom>
+          <a:solidFill>
+            <a:srgbClr val="EEF1F6"/>
+          </a:solidFill>
+          <a:ln>
+            <a:noFill/>
+          </a:ln>
+          <a:effectLst/>
+        </p:spPr>
+        <p:style>
+          <a:lnRef idx="1">
+            <a:schemeClr val="accent1"/>
+          </a:lnRef>
+          <a:fillRef idx="3">
+            <a:schemeClr val="accent1"/>
+          </a:fillRef>
+          <a:effectRef idx="2">
+            <a:schemeClr val="accent1"/>
+          </a:effectRef>
+          <a:fontRef idx="minor">
+            <a:schemeClr val="lt1"/>
+          </a:fontRef>
+        </p:style>
+        <p:txBody>
+          <a:bodyPr rtlCol="0" anchor="ctr"/>
+          <a:lstStyle/>
+          <a:p>
+            <a:pPr algn="ctr"/>
+          </a:p>
+        </p:txBody>
+      </p:sp>
+      <p:sp>
+        <p:nvSpPr>
+          <p:cNvPr id="16" name="TextBox 15"/>
+          <p:cNvSpPr txBox="1"/>
+          <p:nvPr/>
+        </p:nvSpPr>
+        <p:spPr>
+          <a:xfrm>
+            <a:off x="777240" y="5532120"/>
+            <a:ext cx="6492240" cy="320040"/>
+          </a:xfrm>
+          <a:prstGeom prst="rect">
+            <a:avLst/>
+          </a:prstGeom>
+          <a:noFill/>
+        </p:spPr>
+        <p:txBody>
+          <a:bodyPr wrap="square" anchor="t" lIns="0" rIns="0" tIns="0" bIns="0">
+            <a:spAutoFit/>
+          </a:bodyPr>
+          <a:lstStyle/>
+          <a:p>
+            <a:pPr algn="l">
+              <a:spcAft>
+                <a:spcPts val="600"/>
+              </a:spcAft>
+            </a:pPr>
+            <a:r>
+              <a:rPr sz="1300" b="1" i="0">
+                <a:solidFill>
+                  <a:srgbClr val="14213D"/>
+                </a:solidFill>
+                <a:latin typeface="Calibri"/>
+              </a:rPr>
+              <a:t>Net of costs: full sample 2020–2026 / since 2024</a:t>
+            </a:r>
+          </a:p>
+        </p:txBody>
+      </p:sp>
+      <p:sp>
+        <p:nvSpPr>
+          <p:cNvPr id="17" name="TextBox 16"/>
+          <p:cNvSpPr txBox="1"/>
+          <p:nvPr/>
+        </p:nvSpPr>
+        <p:spPr>
+          <a:xfrm>
+            <a:off x="777240" y="5824728"/>
+            <a:ext cx="2072640" cy="411480"/>
+          </a:xfrm>
+          <a:prstGeom prst="rect">
+            <a:avLst/>
+          </a:prstGeom>
+          <a:noFill/>
+        </p:spPr>
+        <p:txBody>
+          <a:bodyPr wrap="square" anchor="t" lIns="0" rIns="0" tIns="0" bIns="0">
+            <a:spAutoFit/>
+          </a:bodyPr>
+          <a:lstStyle/>
+          <a:p>
+            <a:pPr algn="l">
+              <a:spcAft>
+                <a:spcPts val="600"/>
+              </a:spcAft>
+            </a:pPr>
+            <a:r>
+              <a:rPr sz="2000" b="1" i="0">
+                <a:solidFill>
+                  <a:srgbClr val="14213D"/>
+                </a:solidFill>
+                <a:latin typeface="Cambria"/>
+              </a:rPr>
+              <a:t>4.1% / 13.9%</a:t>
+            </a:r>
+          </a:p>
+        </p:txBody>
+      </p:sp>
+      <p:sp>
+        <p:nvSpPr>
+          <p:cNvPr id="18" name="TextBox 17"/>
+          <p:cNvSpPr txBox="1"/>
+          <p:nvPr/>
+        </p:nvSpPr>
+        <p:spPr>
+          <a:xfrm>
+            <a:off x="777240" y="6245352"/>
+            <a:ext cx="2072640" cy="274320"/>
+          </a:xfrm>
+          <a:prstGeom prst="rect">
+            <a:avLst/>
+          </a:prstGeom>
+          <a:noFill/>
+        </p:spPr>
+        <p:txBody>
+          <a:bodyPr wrap="square" anchor="t" lIns="0" rIns="0" tIns="0" bIns="0">
+            <a:spAutoFit/>
+          </a:bodyPr>
+          <a:lstStyle/>
+          <a:p>
+            <a:pPr algn="l">
+              <a:spcAft>
+                <a:spcPts val="600"/>
+              </a:spcAft>
+            </a:pPr>
+            <a:r>
+              <a:rPr sz="1100" b="0" i="0">
+                <a:solidFill>
+                  <a:srgbClr val="5C677D"/>
+                </a:solidFill>
+                <a:latin typeface="Calibri"/>
+              </a:rPr>
+              <a:t>Net return a year</a:t>
+            </a:r>
+          </a:p>
+        </p:txBody>
+      </p:sp>
+      <p:sp>
+        <p:nvSpPr>
+          <p:cNvPr id="19" name="TextBox 18"/>
+          <p:cNvSpPr txBox="1"/>
+          <p:nvPr/>
+        </p:nvSpPr>
+        <p:spPr>
+          <a:xfrm>
+            <a:off x="2941320" y="5824728"/>
+            <a:ext cx="2072640" cy="411480"/>
+          </a:xfrm>
+          <a:prstGeom prst="rect">
+            <a:avLst/>
+          </a:prstGeom>
+          <a:noFill/>
+        </p:spPr>
+        <p:txBody>
+          <a:bodyPr wrap="square" anchor="t" lIns="0" rIns="0" tIns="0" bIns="0">
+            <a:spAutoFit/>
+          </a:bodyPr>
+          <a:lstStyle/>
+          <a:p>
+            <a:pPr algn="l">
+              <a:spcAft>
+                <a:spcPts val="600"/>
+              </a:spcAft>
+            </a:pPr>
+            <a:r>
+              <a:rPr sz="2000" b="1" i="0">
+                <a:solidFill>
+                  <a:srgbClr val="14213D"/>
+                </a:solidFill>
+                <a:latin typeface="Cambria"/>
+              </a:rPr>
+              <a:t>30% / 17%</a:t>
+            </a:r>
+          </a:p>
+        </p:txBody>
+      </p:sp>
+      <p:sp>
+        <p:nvSpPr>
+          <p:cNvPr id="20" name="TextBox 19"/>
+          <p:cNvSpPr txBox="1"/>
+          <p:nvPr/>
+        </p:nvSpPr>
+        <p:spPr>
+          <a:xfrm>
+            <a:off x="2941320" y="6245352"/>
+            <a:ext cx="2072640" cy="274320"/>
+          </a:xfrm>
+          <a:prstGeom prst="rect">
+            <a:avLst/>
+          </a:prstGeom>
+          <a:noFill/>
+        </p:spPr>
+        <p:txBody>
+          <a:bodyPr wrap="square" anchor="t" lIns="0" rIns="0" tIns="0" bIns="0">
+            <a:spAutoFit/>
+          </a:bodyPr>
+          <a:lstStyle/>
+          <a:p>
+            <a:pPr algn="l">
+              <a:spcAft>
+                <a:spcPts val="600"/>
+              </a:spcAft>
+            </a:pPr>
+            <a:r>
+              <a:rPr sz="1100" b="0" i="0">
+                <a:solidFill>
+                  <a:srgbClr val="5C677D"/>
+                </a:solidFill>
+                <a:latin typeface="Calibri"/>
+              </a:rPr>
+              <a:t>Volatility a year</a:t>
+            </a:r>
+          </a:p>
+        </p:txBody>
+      </p:sp>
+      <p:sp>
+        <p:nvSpPr>
+          <p:cNvPr id="21" name="TextBox 20"/>
+          <p:cNvSpPr txBox="1"/>
+          <p:nvPr/>
+        </p:nvSpPr>
+        <p:spPr>
+          <a:xfrm>
+            <a:off x="5105400" y="5824728"/>
+            <a:ext cx="2072640" cy="411480"/>
+          </a:xfrm>
+          <a:prstGeom prst="rect">
+            <a:avLst/>
+          </a:prstGeom>
+          <a:noFill/>
+        </p:spPr>
+        <p:txBody>
+          <a:bodyPr wrap="square" anchor="t" lIns="0" rIns="0" tIns="0" bIns="0">
+            <a:spAutoFit/>
+          </a:bodyPr>
+          <a:lstStyle/>
+          <a:p>
+            <a:pPr algn="l">
+              <a:spcAft>
+                <a:spcPts val="600"/>
+              </a:spcAft>
+            </a:pPr>
+            <a:r>
+              <a:rPr sz="2000" b="1" i="0">
+                <a:solidFill>
+                  <a:srgbClr val="B83227"/>
+                </a:solidFill>
+                <a:latin typeface="Cambria"/>
+              </a:rPr>
+              <a:t>-67% / -13%</a:t>
+            </a:r>
+          </a:p>
+        </p:txBody>
+      </p:sp>
+      <p:sp>
+        <p:nvSpPr>
+          <p:cNvPr id="22" name="TextBox 21"/>
+          <p:cNvSpPr txBox="1"/>
+          <p:nvPr/>
+        </p:nvSpPr>
+        <p:spPr>
+          <a:xfrm>
+            <a:off x="5105400" y="6245352"/>
+            <a:ext cx="2072640" cy="274320"/>
+          </a:xfrm>
+          <a:prstGeom prst="rect">
+            <a:avLst/>
+          </a:prstGeom>
+          <a:noFill/>
+        </p:spPr>
+        <p:txBody>
+          <a:bodyPr wrap="square" anchor="t" lIns="0" rIns="0" tIns="0" bIns="0">
+            <a:spAutoFit/>
+          </a:bodyPr>
+          <a:lstStyle/>
+          <a:p>
+            <a:pPr algn="l">
+              <a:spcAft>
+                <a:spcPts val="600"/>
+              </a:spcAft>
+            </a:pPr>
+            <a:r>
+              <a:rPr sz="1100" b="0" i="0">
+                <a:solidFill>
+                  <a:srgbClr val="5C677D"/>
+                </a:solidFill>
+                <a:latin typeface="Calibri"/>
+              </a:rPr>
+              <a:t>Max drawdown</a:t>
             </a:r>
           </a:p>
         </p:txBody>
@@ -10137,7 +11342,46 @@
       </p:sp>
       <p:sp>
         <p:nvSpPr>
-          <p:cNvPr id="7" name="Rounded Rectangle 6"/>
+          <p:cNvPr id="7" name="TextBox 6"/>
+          <p:cNvSpPr txBox="1"/>
+          <p:nvPr/>
+        </p:nvSpPr>
+        <p:spPr>
+          <a:xfrm>
+            <a:off x="548640" y="5897880"/>
+            <a:ext cx="5394960" cy="731520"/>
+          </a:xfrm>
+          <a:prstGeom prst="rect">
+            <a:avLst/>
+          </a:prstGeom>
+          <a:noFill/>
+        </p:spPr>
+        <p:txBody>
+          <a:bodyPr wrap="square" anchor="t" lIns="0" rIns="0" tIns="0" bIns="0">
+            <a:spAutoFit/>
+          </a:bodyPr>
+          <a:lstStyle/>
+          <a:p>
+            <a:pPr algn="l">
+              <a:spcAft>
+                <a:spcPts val="600"/>
+              </a:spcAft>
+            </a:pPr>
+            <a:r>
+              <a:rPr sz="1200" b="1" i="0">
+                <a:solidFill>
+                  <a:srgbClr val="14213D"/>
+                </a:solidFill>
+                <a:latin typeface="Calibri"/>
+              </a:rPr>
+              <a:t>Robustness: all 6 lookback and rebalancing settings have a positive out-of-sample Sharpe (0.41 to 1.29); our pre-set choice is in the bottom half.</a:t>
+            </a:r>
+          </a:p>
+        </p:txBody>
+      </p:sp>
+      <p:sp>
+        <p:nvSpPr>
+          <p:cNvPr id="8" name="Rounded Rectangle 7"/>
           <p:cNvSpPr/>
           <p:nvPr/>
         </p:nvSpPr>
@@ -10183,7 +11427,7 @@
       </p:sp>
       <p:sp>
         <p:nvSpPr>
-          <p:cNvPr id="8" name="TextBox 7"/>
+          <p:cNvPr id="9" name="TextBox 8"/>
           <p:cNvSpPr txBox="1"/>
           <p:nvPr/>
         </p:nvSpPr>
@@ -10222,7 +11466,7 @@
       </p:sp>
       <p:sp>
         <p:nvSpPr>
-          <p:cNvPr id="9" name="TextBox 8"/>
+          <p:cNvPr id="10" name="TextBox 9"/>
           <p:cNvSpPr txBox="1"/>
           <p:nvPr/>
         </p:nvSpPr>

</xml_diff>

<commit_message>
10-minute deck: performance boxes as labelled rows instead of paired values
</commit_message>
<xml_diff>
--- a/slides/presentation_10min.pptx
+++ b/slides/presentation_10min.pptx
@@ -8912,8 +8912,8 @@
         </p:nvSpPr>
         <p:spPr>
           <a:xfrm>
-            <a:off x="777240" y="5440679"/>
-            <a:ext cx="6675120" cy="320040"/>
+            <a:off x="777240" y="5477255"/>
+            <a:ext cx="2103120" cy="274320"/>
           </a:xfrm>
           <a:prstGeom prst="rect">
             <a:avLst/>
@@ -8932,13 +8932,13 @@
               </a:spcAft>
             </a:pPr>
             <a:r>
-              <a:rPr sz="1300" b="1" i="0">
+              <a:rPr sz="1200" b="1" i="0">
                 <a:solidFill>
                   <a:srgbClr val="14213D"/>
                 </a:solidFill>
                 <a:latin typeface="Calibri"/>
               </a:rPr>
-              <a:t>Full sample 1999–2026, net of costs: carry / crowd-filtered</a:t>
+              <a:t>Net, 1999–2026</a:t>
             </a:r>
           </a:p>
         </p:txBody>
@@ -8951,8 +8951,8 @@
         </p:nvSpPr>
         <p:spPr>
           <a:xfrm>
-            <a:off x="777240" y="5733288"/>
-            <a:ext cx="2133599" cy="411480"/>
+            <a:off x="2880360" y="5477255"/>
+            <a:ext cx="1432560" cy="274320"/>
           </a:xfrm>
           <a:prstGeom prst="rect">
             <a:avLst/>
@@ -8971,13 +8971,13 @@
               </a:spcAft>
             </a:pPr>
             <a:r>
-              <a:rPr sz="2000" b="1" i="0">
-                <a:solidFill>
-                  <a:srgbClr val="14213D"/>
-                </a:solidFill>
-                <a:latin typeface="Cambria"/>
-              </a:rPr>
-              <a:t>3.3% / 3.2%</a:t>
+              <a:rPr sz="1200" b="0" i="0">
+                <a:solidFill>
+                  <a:srgbClr val="5C677D"/>
+                </a:solidFill>
+                <a:latin typeface="Calibri"/>
+              </a:rPr>
+              <a:t>Net return a year</a:t>
             </a:r>
           </a:p>
         </p:txBody>
@@ -8990,8 +8990,8 @@
         </p:nvSpPr>
         <p:spPr>
           <a:xfrm>
-            <a:off x="777240" y="6153912"/>
-            <a:ext cx="2133599" cy="274320"/>
+            <a:off x="4404360" y="5477255"/>
+            <a:ext cx="1432560" cy="274320"/>
           </a:xfrm>
           <a:prstGeom prst="rect">
             <a:avLst/>
@@ -9010,13 +9010,13 @@
               </a:spcAft>
             </a:pPr>
             <a:r>
-              <a:rPr sz="1100" b="0" i="0">
+              <a:rPr sz="1200" b="0" i="0">
                 <a:solidFill>
                   <a:srgbClr val="5C677D"/>
                 </a:solidFill>
                 <a:latin typeface="Calibri"/>
               </a:rPr>
-              <a:t>Net return a year</a:t>
+              <a:t>Volatility a year</a:t>
             </a:r>
           </a:p>
         </p:txBody>
@@ -9029,8 +9029,8 @@
         </p:nvSpPr>
         <p:spPr>
           <a:xfrm>
-            <a:off x="3002280" y="5733288"/>
-            <a:ext cx="2133599" cy="411480"/>
+            <a:off x="5928360" y="5477255"/>
+            <a:ext cx="1432560" cy="274320"/>
           </a:xfrm>
           <a:prstGeom prst="rect">
             <a:avLst/>
@@ -9049,13 +9049,13 @@
               </a:spcAft>
             </a:pPr>
             <a:r>
-              <a:rPr sz="2000" b="1" i="0">
-                <a:solidFill>
-                  <a:srgbClr val="14213D"/>
-                </a:solidFill>
-                <a:latin typeface="Cambria"/>
-              </a:rPr>
-              <a:t>8.9% / 8.5%</a:t>
+              <a:rPr sz="1200" b="0" i="0">
+                <a:solidFill>
+                  <a:srgbClr val="5C677D"/>
+                </a:solidFill>
+                <a:latin typeface="Calibri"/>
+              </a:rPr>
+              <a:t>Max drawdown</a:t>
             </a:r>
           </a:p>
         </p:txBody>
@@ -9068,8 +9068,8 @@
         </p:nvSpPr>
         <p:spPr>
           <a:xfrm>
-            <a:off x="3002280" y="6153912"/>
-            <a:ext cx="2133599" cy="274320"/>
+            <a:off x="777240" y="5806440"/>
+            <a:ext cx="2103120" cy="320040"/>
           </a:xfrm>
           <a:prstGeom prst="rect">
             <a:avLst/>
@@ -9088,13 +9088,13 @@
               </a:spcAft>
             </a:pPr>
             <a:r>
-              <a:rPr sz="1100" b="0" i="0">
-                <a:solidFill>
-                  <a:srgbClr val="5C677D"/>
+              <a:rPr sz="1400" b="0" i="0">
+                <a:solidFill>
+                  <a:srgbClr val="14213D"/>
                 </a:solidFill>
                 <a:latin typeface="Calibri"/>
               </a:rPr>
-              <a:t>Volatility a year</a:t>
+              <a:t>Carry</a:t>
             </a:r>
           </a:p>
         </p:txBody>
@@ -9107,8 +9107,8 @@
         </p:nvSpPr>
         <p:spPr>
           <a:xfrm>
-            <a:off x="5227319" y="5733288"/>
-            <a:ext cx="2133599" cy="411480"/>
+            <a:off x="2880360" y="5806440"/>
+            <a:ext cx="1432560" cy="320040"/>
           </a:xfrm>
           <a:prstGeom prst="rect">
             <a:avLst/>
@@ -9127,13 +9127,13 @@
               </a:spcAft>
             </a:pPr>
             <a:r>
-              <a:rPr sz="2000" b="1" i="0">
-                <a:solidFill>
-                  <a:srgbClr val="B83227"/>
+              <a:rPr sz="1600" b="1" i="0">
+                <a:solidFill>
+                  <a:srgbClr val="14213D"/>
                 </a:solidFill>
                 <a:latin typeface="Cambria"/>
               </a:rPr>
-              <a:t>-37% / -37%</a:t>
+              <a:t>3.3%</a:t>
             </a:r>
           </a:p>
         </p:txBody>
@@ -9146,8 +9146,8 @@
         </p:nvSpPr>
         <p:spPr>
           <a:xfrm>
-            <a:off x="5227319" y="6153912"/>
-            <a:ext cx="2133599" cy="274320"/>
+            <a:off x="4404360" y="5806440"/>
+            <a:ext cx="1432560" cy="320040"/>
           </a:xfrm>
           <a:prstGeom prst="rect">
             <a:avLst/>
@@ -9166,13 +9166,208 @@
               </a:spcAft>
             </a:pPr>
             <a:r>
-              <a:rPr sz="1100" b="0" i="0">
-                <a:solidFill>
-                  <a:srgbClr val="5C677D"/>
+              <a:rPr sz="1600" b="1" i="0">
+                <a:solidFill>
+                  <a:srgbClr val="14213D"/>
+                </a:solidFill>
+                <a:latin typeface="Cambria"/>
+              </a:rPr>
+              <a:t>8.9%</a:t>
+            </a:r>
+          </a:p>
+        </p:txBody>
+      </p:sp>
+      <p:sp>
+        <p:nvSpPr>
+          <p:cNvPr id="21" name="TextBox 20"/>
+          <p:cNvSpPr txBox="1"/>
+          <p:nvPr/>
+        </p:nvSpPr>
+        <p:spPr>
+          <a:xfrm>
+            <a:off x="5928360" y="5806440"/>
+            <a:ext cx="1432560" cy="320040"/>
+          </a:xfrm>
+          <a:prstGeom prst="rect">
+            <a:avLst/>
+          </a:prstGeom>
+          <a:noFill/>
+        </p:spPr>
+        <p:txBody>
+          <a:bodyPr wrap="square" anchor="t" lIns="0" rIns="0" tIns="0" bIns="0">
+            <a:spAutoFit/>
+          </a:bodyPr>
+          <a:lstStyle/>
+          <a:p>
+            <a:pPr algn="l">
+              <a:spcAft>
+                <a:spcPts val="600"/>
+              </a:spcAft>
+            </a:pPr>
+            <a:r>
+              <a:rPr sz="1600" b="1" i="0">
+                <a:solidFill>
+                  <a:srgbClr val="B83227"/>
+                </a:solidFill>
+                <a:latin typeface="Cambria"/>
+              </a:rPr>
+              <a:t>-37%</a:t>
+            </a:r>
+          </a:p>
+        </p:txBody>
+      </p:sp>
+      <p:sp>
+        <p:nvSpPr>
+          <p:cNvPr id="22" name="TextBox 21"/>
+          <p:cNvSpPr txBox="1"/>
+          <p:nvPr/>
+        </p:nvSpPr>
+        <p:spPr>
+          <a:xfrm>
+            <a:off x="777240" y="6153912"/>
+            <a:ext cx="2103120" cy="320040"/>
+          </a:xfrm>
+          <a:prstGeom prst="rect">
+            <a:avLst/>
+          </a:prstGeom>
+          <a:noFill/>
+        </p:spPr>
+        <p:txBody>
+          <a:bodyPr wrap="square" anchor="t" lIns="0" rIns="0" tIns="0" bIns="0">
+            <a:spAutoFit/>
+          </a:bodyPr>
+          <a:lstStyle/>
+          <a:p>
+            <a:pPr algn="l">
+              <a:spcAft>
+                <a:spcPts val="600"/>
+              </a:spcAft>
+            </a:pPr>
+            <a:r>
+              <a:rPr sz="1400" b="0" i="0">
+                <a:solidFill>
+                  <a:srgbClr val="14213D"/>
                 </a:solidFill>
                 <a:latin typeface="Calibri"/>
               </a:rPr>
-              <a:t>Max drawdown</a:t>
+              <a:t>Crowd-filtered</a:t>
+            </a:r>
+          </a:p>
+        </p:txBody>
+      </p:sp>
+      <p:sp>
+        <p:nvSpPr>
+          <p:cNvPr id="23" name="TextBox 22"/>
+          <p:cNvSpPr txBox="1"/>
+          <p:nvPr/>
+        </p:nvSpPr>
+        <p:spPr>
+          <a:xfrm>
+            <a:off x="2880360" y="6153912"/>
+            <a:ext cx="1432560" cy="320040"/>
+          </a:xfrm>
+          <a:prstGeom prst="rect">
+            <a:avLst/>
+          </a:prstGeom>
+          <a:noFill/>
+        </p:spPr>
+        <p:txBody>
+          <a:bodyPr wrap="square" anchor="t" lIns="0" rIns="0" tIns="0" bIns="0">
+            <a:spAutoFit/>
+          </a:bodyPr>
+          <a:lstStyle/>
+          <a:p>
+            <a:pPr algn="l">
+              <a:spcAft>
+                <a:spcPts val="600"/>
+              </a:spcAft>
+            </a:pPr>
+            <a:r>
+              <a:rPr sz="1600" b="1" i="0">
+                <a:solidFill>
+                  <a:srgbClr val="14213D"/>
+                </a:solidFill>
+                <a:latin typeface="Cambria"/>
+              </a:rPr>
+              <a:t>3.2%</a:t>
+            </a:r>
+          </a:p>
+        </p:txBody>
+      </p:sp>
+      <p:sp>
+        <p:nvSpPr>
+          <p:cNvPr id="24" name="TextBox 23"/>
+          <p:cNvSpPr txBox="1"/>
+          <p:nvPr/>
+        </p:nvSpPr>
+        <p:spPr>
+          <a:xfrm>
+            <a:off x="4404360" y="6153912"/>
+            <a:ext cx="1432560" cy="320040"/>
+          </a:xfrm>
+          <a:prstGeom prst="rect">
+            <a:avLst/>
+          </a:prstGeom>
+          <a:noFill/>
+        </p:spPr>
+        <p:txBody>
+          <a:bodyPr wrap="square" anchor="t" lIns="0" rIns="0" tIns="0" bIns="0">
+            <a:spAutoFit/>
+          </a:bodyPr>
+          <a:lstStyle/>
+          <a:p>
+            <a:pPr algn="l">
+              <a:spcAft>
+                <a:spcPts val="600"/>
+              </a:spcAft>
+            </a:pPr>
+            <a:r>
+              <a:rPr sz="1600" b="1" i="0">
+                <a:solidFill>
+                  <a:srgbClr val="14213D"/>
+                </a:solidFill>
+                <a:latin typeface="Cambria"/>
+              </a:rPr>
+              <a:t>8.5%</a:t>
+            </a:r>
+          </a:p>
+        </p:txBody>
+      </p:sp>
+      <p:sp>
+        <p:nvSpPr>
+          <p:cNvPr id="25" name="TextBox 24"/>
+          <p:cNvSpPr txBox="1"/>
+          <p:nvPr/>
+        </p:nvSpPr>
+        <p:spPr>
+          <a:xfrm>
+            <a:off x="5928360" y="6153912"/>
+            <a:ext cx="1432560" cy="320040"/>
+          </a:xfrm>
+          <a:prstGeom prst="rect">
+            <a:avLst/>
+          </a:prstGeom>
+          <a:noFill/>
+        </p:spPr>
+        <p:txBody>
+          <a:bodyPr wrap="square" anchor="t" lIns="0" rIns="0" tIns="0" bIns="0">
+            <a:spAutoFit/>
+          </a:bodyPr>
+          <a:lstStyle/>
+          <a:p>
+            <a:pPr algn="l">
+              <a:spcAft>
+                <a:spcPts val="600"/>
+              </a:spcAft>
+            </a:pPr>
+            <a:r>
+              <a:rPr sz="1600" b="1" i="0">
+                <a:solidFill>
+                  <a:srgbClr val="B83227"/>
+                </a:solidFill>
+                <a:latin typeface="Cambria"/>
+              </a:rPr>
+              <a:t>-37%</a:t>
             </a:r>
           </a:p>
         </p:txBody>
@@ -10504,8 +10699,8 @@
         </p:nvSpPr>
         <p:spPr>
           <a:xfrm>
-            <a:off x="777240" y="5532120"/>
-            <a:ext cx="6492240" cy="320040"/>
+            <a:off x="777240" y="5568696"/>
+            <a:ext cx="2103120" cy="274320"/>
           </a:xfrm>
           <a:prstGeom prst="rect">
             <a:avLst/>
@@ -10524,13 +10719,13 @@
               </a:spcAft>
             </a:pPr>
             <a:r>
-              <a:rPr sz="1300" b="1" i="0">
+              <a:rPr sz="1200" b="1" i="0">
                 <a:solidFill>
                   <a:srgbClr val="14213D"/>
                 </a:solidFill>
                 <a:latin typeface="Calibri"/>
               </a:rPr>
-              <a:t>Net of costs: full sample 2020–2026 / since 2024</a:t>
+              <a:t>Net of costs</a:t>
             </a:r>
           </a:p>
         </p:txBody>
@@ -10543,8 +10738,8 @@
         </p:nvSpPr>
         <p:spPr>
           <a:xfrm>
-            <a:off x="777240" y="5824728"/>
-            <a:ext cx="2072640" cy="411480"/>
+            <a:off x="2880360" y="5568696"/>
+            <a:ext cx="1371599" cy="274320"/>
           </a:xfrm>
           <a:prstGeom prst="rect">
             <a:avLst/>
@@ -10563,13 +10758,13 @@
               </a:spcAft>
             </a:pPr>
             <a:r>
-              <a:rPr sz="2000" b="1" i="0">
-                <a:solidFill>
-                  <a:srgbClr val="14213D"/>
-                </a:solidFill>
-                <a:latin typeface="Cambria"/>
-              </a:rPr>
-              <a:t>4.1% / 13.9%</a:t>
+              <a:rPr sz="1200" b="0" i="0">
+                <a:solidFill>
+                  <a:srgbClr val="5C677D"/>
+                </a:solidFill>
+                <a:latin typeface="Calibri"/>
+              </a:rPr>
+              <a:t>Net return a year</a:t>
             </a:r>
           </a:p>
         </p:txBody>
@@ -10582,8 +10777,8 @@
         </p:nvSpPr>
         <p:spPr>
           <a:xfrm>
-            <a:off x="777240" y="6245352"/>
-            <a:ext cx="2072640" cy="274320"/>
+            <a:off x="4343400" y="5568696"/>
+            <a:ext cx="1371599" cy="274320"/>
           </a:xfrm>
           <a:prstGeom prst="rect">
             <a:avLst/>
@@ -10602,13 +10797,13 @@
               </a:spcAft>
             </a:pPr>
             <a:r>
-              <a:rPr sz="1100" b="0" i="0">
+              <a:rPr sz="1200" b="0" i="0">
                 <a:solidFill>
                   <a:srgbClr val="5C677D"/>
                 </a:solidFill>
                 <a:latin typeface="Calibri"/>
               </a:rPr>
-              <a:t>Net return a year</a:t>
+              <a:t>Volatility a year</a:t>
             </a:r>
           </a:p>
         </p:txBody>
@@ -10621,8 +10816,8 @@
         </p:nvSpPr>
         <p:spPr>
           <a:xfrm>
-            <a:off x="2941320" y="5824728"/>
-            <a:ext cx="2072640" cy="411480"/>
+            <a:off x="5806440" y="5568696"/>
+            <a:ext cx="1371599" cy="274320"/>
           </a:xfrm>
           <a:prstGeom prst="rect">
             <a:avLst/>
@@ -10641,13 +10836,13 @@
               </a:spcAft>
             </a:pPr>
             <a:r>
-              <a:rPr sz="2000" b="1" i="0">
-                <a:solidFill>
-                  <a:srgbClr val="14213D"/>
-                </a:solidFill>
-                <a:latin typeface="Cambria"/>
-              </a:rPr>
-              <a:t>30% / 17%</a:t>
+              <a:rPr sz="1200" b="0" i="0">
+                <a:solidFill>
+                  <a:srgbClr val="5C677D"/>
+                </a:solidFill>
+                <a:latin typeface="Calibri"/>
+              </a:rPr>
+              <a:t>Max drawdown</a:t>
             </a:r>
           </a:p>
         </p:txBody>
@@ -10660,8 +10855,8 @@
         </p:nvSpPr>
         <p:spPr>
           <a:xfrm>
-            <a:off x="2941320" y="6245352"/>
-            <a:ext cx="2072640" cy="274320"/>
+            <a:off x="777240" y="5897880"/>
+            <a:ext cx="2103120" cy="320040"/>
           </a:xfrm>
           <a:prstGeom prst="rect">
             <a:avLst/>
@@ -10680,13 +10875,13 @@
               </a:spcAft>
             </a:pPr>
             <a:r>
-              <a:rPr sz="1100" b="0" i="0">
-                <a:solidFill>
-                  <a:srgbClr val="5C677D"/>
+              <a:rPr sz="1400" b="0" i="0">
+                <a:solidFill>
+                  <a:srgbClr val="14213D"/>
                 </a:solidFill>
                 <a:latin typeface="Calibri"/>
               </a:rPr>
-              <a:t>Volatility a year</a:t>
+              <a:t>Full sample 2020–26</a:t>
             </a:r>
           </a:p>
         </p:txBody>
@@ -10699,8 +10894,8 @@
         </p:nvSpPr>
         <p:spPr>
           <a:xfrm>
-            <a:off x="5105400" y="5824728"/>
-            <a:ext cx="2072640" cy="411480"/>
+            <a:off x="2880360" y="5897880"/>
+            <a:ext cx="1371599" cy="320040"/>
           </a:xfrm>
           <a:prstGeom prst="rect">
             <a:avLst/>
@@ -10719,13 +10914,13 @@
               </a:spcAft>
             </a:pPr>
             <a:r>
-              <a:rPr sz="2000" b="1" i="0">
-                <a:solidFill>
-                  <a:srgbClr val="B83227"/>
+              <a:rPr sz="1600" b="1" i="0">
+                <a:solidFill>
+                  <a:srgbClr val="14213D"/>
                 </a:solidFill>
                 <a:latin typeface="Cambria"/>
               </a:rPr>
-              <a:t>-67% / -13%</a:t>
+              <a:t>4.1%</a:t>
             </a:r>
           </a:p>
         </p:txBody>
@@ -10738,8 +10933,8 @@
         </p:nvSpPr>
         <p:spPr>
           <a:xfrm>
-            <a:off x="5105400" y="6245352"/>
-            <a:ext cx="2072640" cy="274320"/>
+            <a:off x="4343400" y="5897880"/>
+            <a:ext cx="1371599" cy="320040"/>
           </a:xfrm>
           <a:prstGeom prst="rect">
             <a:avLst/>
@@ -10758,13 +10953,208 @@
               </a:spcAft>
             </a:pPr>
             <a:r>
-              <a:rPr sz="1100" b="0" i="0">
-                <a:solidFill>
-                  <a:srgbClr val="5C677D"/>
+              <a:rPr sz="1600" b="1" i="0">
+                <a:solidFill>
+                  <a:srgbClr val="14213D"/>
+                </a:solidFill>
+                <a:latin typeface="Cambria"/>
+              </a:rPr>
+              <a:t>30%</a:t>
+            </a:r>
+          </a:p>
+        </p:txBody>
+      </p:sp>
+      <p:sp>
+        <p:nvSpPr>
+          <p:cNvPr id="23" name="TextBox 22"/>
+          <p:cNvSpPr txBox="1"/>
+          <p:nvPr/>
+        </p:nvSpPr>
+        <p:spPr>
+          <a:xfrm>
+            <a:off x="5806440" y="5897880"/>
+            <a:ext cx="1371599" cy="320040"/>
+          </a:xfrm>
+          <a:prstGeom prst="rect">
+            <a:avLst/>
+          </a:prstGeom>
+          <a:noFill/>
+        </p:spPr>
+        <p:txBody>
+          <a:bodyPr wrap="square" anchor="t" lIns="0" rIns="0" tIns="0" bIns="0">
+            <a:spAutoFit/>
+          </a:bodyPr>
+          <a:lstStyle/>
+          <a:p>
+            <a:pPr algn="l">
+              <a:spcAft>
+                <a:spcPts val="600"/>
+              </a:spcAft>
+            </a:pPr>
+            <a:r>
+              <a:rPr sz="1600" b="1" i="0">
+                <a:solidFill>
+                  <a:srgbClr val="B83227"/>
+                </a:solidFill>
+                <a:latin typeface="Cambria"/>
+              </a:rPr>
+              <a:t>-67%</a:t>
+            </a:r>
+          </a:p>
+        </p:txBody>
+      </p:sp>
+      <p:sp>
+        <p:nvSpPr>
+          <p:cNvPr id="24" name="TextBox 23"/>
+          <p:cNvSpPr txBox="1"/>
+          <p:nvPr/>
+        </p:nvSpPr>
+        <p:spPr>
+          <a:xfrm>
+            <a:off x="777240" y="6245352"/>
+            <a:ext cx="2103120" cy="320040"/>
+          </a:xfrm>
+          <a:prstGeom prst="rect">
+            <a:avLst/>
+          </a:prstGeom>
+          <a:noFill/>
+        </p:spPr>
+        <p:txBody>
+          <a:bodyPr wrap="square" anchor="t" lIns="0" rIns="0" tIns="0" bIns="0">
+            <a:spAutoFit/>
+          </a:bodyPr>
+          <a:lstStyle/>
+          <a:p>
+            <a:pPr algn="l">
+              <a:spcAft>
+                <a:spcPts val="600"/>
+              </a:spcAft>
+            </a:pPr>
+            <a:r>
+              <a:rPr sz="1400" b="0" i="0">
+                <a:solidFill>
+                  <a:srgbClr val="14213D"/>
                 </a:solidFill>
                 <a:latin typeface="Calibri"/>
               </a:rPr>
-              <a:t>Max drawdown</a:t>
+              <a:t>Since 2024</a:t>
+            </a:r>
+          </a:p>
+        </p:txBody>
+      </p:sp>
+      <p:sp>
+        <p:nvSpPr>
+          <p:cNvPr id="25" name="TextBox 24"/>
+          <p:cNvSpPr txBox="1"/>
+          <p:nvPr/>
+        </p:nvSpPr>
+        <p:spPr>
+          <a:xfrm>
+            <a:off x="2880360" y="6245352"/>
+            <a:ext cx="1371599" cy="320040"/>
+          </a:xfrm>
+          <a:prstGeom prst="rect">
+            <a:avLst/>
+          </a:prstGeom>
+          <a:noFill/>
+        </p:spPr>
+        <p:txBody>
+          <a:bodyPr wrap="square" anchor="t" lIns="0" rIns="0" tIns="0" bIns="0">
+            <a:spAutoFit/>
+          </a:bodyPr>
+          <a:lstStyle/>
+          <a:p>
+            <a:pPr algn="l">
+              <a:spcAft>
+                <a:spcPts val="600"/>
+              </a:spcAft>
+            </a:pPr>
+            <a:r>
+              <a:rPr sz="1600" b="1" i="0">
+                <a:solidFill>
+                  <a:srgbClr val="14213D"/>
+                </a:solidFill>
+                <a:latin typeface="Cambria"/>
+              </a:rPr>
+              <a:t>13.9%</a:t>
+            </a:r>
+          </a:p>
+        </p:txBody>
+      </p:sp>
+      <p:sp>
+        <p:nvSpPr>
+          <p:cNvPr id="26" name="TextBox 25"/>
+          <p:cNvSpPr txBox="1"/>
+          <p:nvPr/>
+        </p:nvSpPr>
+        <p:spPr>
+          <a:xfrm>
+            <a:off x="4343400" y="6245352"/>
+            <a:ext cx="1371599" cy="320040"/>
+          </a:xfrm>
+          <a:prstGeom prst="rect">
+            <a:avLst/>
+          </a:prstGeom>
+          <a:noFill/>
+        </p:spPr>
+        <p:txBody>
+          <a:bodyPr wrap="square" anchor="t" lIns="0" rIns="0" tIns="0" bIns="0">
+            <a:spAutoFit/>
+          </a:bodyPr>
+          <a:lstStyle/>
+          <a:p>
+            <a:pPr algn="l">
+              <a:spcAft>
+                <a:spcPts val="600"/>
+              </a:spcAft>
+            </a:pPr>
+            <a:r>
+              <a:rPr sz="1600" b="1" i="0">
+                <a:solidFill>
+                  <a:srgbClr val="14213D"/>
+                </a:solidFill>
+                <a:latin typeface="Cambria"/>
+              </a:rPr>
+              <a:t>17%</a:t>
+            </a:r>
+          </a:p>
+        </p:txBody>
+      </p:sp>
+      <p:sp>
+        <p:nvSpPr>
+          <p:cNvPr id="27" name="TextBox 26"/>
+          <p:cNvSpPr txBox="1"/>
+          <p:nvPr/>
+        </p:nvSpPr>
+        <p:spPr>
+          <a:xfrm>
+            <a:off x="5806440" y="6245352"/>
+            <a:ext cx="1371599" cy="320040"/>
+          </a:xfrm>
+          <a:prstGeom prst="rect">
+            <a:avLst/>
+          </a:prstGeom>
+          <a:noFill/>
+        </p:spPr>
+        <p:txBody>
+          <a:bodyPr wrap="square" anchor="t" lIns="0" rIns="0" tIns="0" bIns="0">
+            <a:spAutoFit/>
+          </a:bodyPr>
+          <a:lstStyle/>
+          <a:p>
+            <a:pPr algn="l">
+              <a:spcAft>
+                <a:spcPts val="600"/>
+              </a:spcAft>
+            </a:pPr>
+            <a:r>
+              <a:rPr sz="1600" b="1" i="0">
+                <a:solidFill>
+                  <a:srgbClr val="B83227"/>
+                </a:solidFill>
+                <a:latin typeface="Cambria"/>
+              </a:rPr>
+              <a:t>-13%</a:t>
             </a:r>
           </a:p>
         </p:txBody>

</xml_diff>

<commit_message>
10-minute deck: bold main question on slide 2
</commit_message>
<xml_diff>
--- a/slides/presentation_10min.pptx
+++ b/slides/presentation_10min.pptx
@@ -5854,9 +5854,9 @@
               </a:spcAft>
             </a:pPr>
             <a:r>
-              <a:rPr sz="1600" b="0" i="0">
-                <a:solidFill>
-                  <a:srgbClr val="5C677D"/>
+              <a:rPr sz="1800" b="1" i="0">
+                <a:solidFill>
+                  <a:srgbClr val="14213D"/>
                 </a:solidFill>
                 <a:latin typeface="Calibri"/>
               </a:rPr>

</xml_diff>

<commit_message>
10-minute deck: up-the-stairs line on slide 1, bold key takeaways on crypto drivers slide
</commit_message>
<xml_diff>
--- a/slides/presentation_10min.pptx
+++ b/slides/presentation_10min.pptx
@@ -7267,6 +7267,22 @@
               </a:spcAft>
             </a:pPr>
             <a:r>
+              <a:rPr sz="1400" b="1" i="0">
+                <a:solidFill>
+                  <a:srgbClr val="14213D"/>
+                </a:solidFill>
+                <a:latin typeface="Calibri"/>
+              </a:rPr>
+              <a:t>•  Carry goes “up the stairs and down the elevator”: small steady gains most of the time, then large losses in a few weeks.</a:t>
+            </a:r>
+          </a:p>
+          <a:p>
+            <a:pPr algn="l">
+              <a:spcAft>
+                <a:spcPts val="700"/>
+              </a:spcAft>
+            </a:pPr>
+            <a:r>
               <a:rPr sz="1400" b="0" i="0">
                 <a:solidFill>
                   <a:srgbClr val="1B1F27"/>
@@ -14900,9 +14916,9 @@
               </a:spcAft>
             </a:pPr>
             <a:r>
-              <a:rPr sz="1300" b="0" i="0">
-                <a:solidFill>
-                  <a:srgbClr val="1B1F27"/>
+              <a:rPr sz="1300" b="1" i="0">
+                <a:solidFill>
+                  <a:srgbClr val="14213D"/>
                 </a:solidFill>
                 <a:latin typeface="Calibri"/>
               </a:rPr>
@@ -14916,9 +14932,9 @@
               </a:spcAft>
             </a:pPr>
             <a:r>
-              <a:rPr sz="1300" b="0" i="0">
-                <a:solidFill>
-                  <a:srgbClr val="1B1F27"/>
+              <a:rPr sz="1300" b="1" i="0">
+                <a:solidFill>
+                  <a:srgbClr val="14213D"/>
                 </a:solidFill>
                 <a:latin typeface="Calibri"/>
               </a:rPr>

</xml_diff>

<commit_message>
Rewrite README (question, answer, hypotheses, data, approach, model, figures, tables); drop risk control from README and 10-minute deck
</commit_message>
<xml_diff>
--- a/slides/presentation_10min.pptx
+++ b/slides/presentation_10min.pptx
@@ -742,7 +742,7 @@
           </a:p>
           <a:p>
             <a:r>
-              <a:t>• The table sums up our hypotheses: four are supported, crowding in FX leans yes, crypto funding carry is mixed, and our pre-set risk control did not work.</a:t>
+              <a:t>• The table sums up our hypotheses: four are supported, crowding in FX leans yes, and crypto funding carry is mixed.</a:t>
             </a:r>
           </a:p>
           <a:p>
@@ -1652,11 +1652,6 @@
           </a:p>
           <a:p>
             <a:r>
-              <a:t>• A risk control we fixed in advance made things worse and lowered the Sharpe to -0.16: the cap halved exposure and the filter missed the timing of Terra's collapse.</a:t>
-            </a:r>
-          </a:p>
-          <a:p>
-            <a:r>
               <a:t>• Our takeaway is that crypto carry crashes in the mirror image of FX: it ends up long whatever traders short hardest.</a:t>
             </a:r>
           </a:p>
@@ -1678,16 +1673,6 @@
           <a:p>
             <a:r>
               <a:t>• Since 2024 funding paid only 3.1%, and price moves added 13.0%, which is luck rather than carry.</a:t>
-            </a:r>
-          </a:p>
-          <a:p>
-            <a:r>
-              <a:t>• The risk control capped each coin at one sixth of its side of the book and refused to buy coins with 7-day funding below minus 50% a year.</a:t>
-            </a:r>
-          </a:p>
-          <a:p>
-            <a:r>
-              <a:t>• It failed because the cap left part of the book in cash and halved the funding income, and on the Sunday before Terra collapsed its 7-day funding was only about minus 20% a year, so the filter did not remove it.</a:t>
             </a:r>
           </a:p>
         </p:txBody>
@@ -6227,7 +6212,7 @@
         </p:nvGraphicFramePr>
         <p:xfrm>
           <a:off x="548640" y="3383280"/>
-          <a:ext cx="6949440" cy="3072384"/>
+          <a:ext cx="6949440" cy="2688336"/>
         </p:xfrm>
         <a:graphic>
           <a:graphicData uri="http://schemas.openxmlformats.org/drawingml/2006/table">
@@ -6680,7 +6665,7 @@
                           </a:solidFill>
                           <a:latin typeface="Calibri"/>
                         </a:rPr>
-                        <a:t>Pre-set risk control helps</a:t>
+                        <a:t>FX and crypto carry diversify</a:t>
                       </a:r>
                     </a:p>
                   </a:txBody>
@@ -6699,11 +6684,11 @@
                       <a:r>
                         <a:rPr sz="1000" b="1">
                           <a:solidFill>
-                            <a:srgbClr val="B83227"/>
+                            <a:srgbClr val="2E7D4F"/>
                           </a:solidFill>
                           <a:latin typeface="Calibri"/>
                         </a:rPr>
-                        <a:t>Not supported</a:t>
+                        <a:t>Supported</a:t>
                       </a:r>
                     </a:p>
                   </a:txBody>
@@ -6726,84 +6711,13 @@
                           </a:solidFill>
                           <a:latin typeface="Calibri"/>
                         </a:rPr>
-                        <a:t>Sharpe 0.14 → -0.16</a:t>
+                        <a:t>Correlation 0.11; vol 7.0% vs about 9%</a:t>
                       </a:r>
                     </a:p>
                   </a:txBody>
                   <a:tcPr marL="73152" marR="73152">
                     <a:solidFill>
                       <a:srgbClr val="EEF1F6"/>
-                    </a:solidFill>
-                  </a:tcPr>
-                </a:tc>
-              </a:tr>
-              <a:tr h="384048">
-                <a:tc>
-                  <a:txBody>
-                    <a:bodyPr/>
-                    <a:lstStyle/>
-                    <a:p>
-                      <a:pPr algn="l"/>
-                      <a:r>
-                        <a:rPr sz="1000" b="0">
-                          <a:solidFill>
-                            <a:srgbClr val="1B1F27"/>
-                          </a:solidFill>
-                          <a:latin typeface="Calibri"/>
-                        </a:rPr>
-                        <a:t>FX and crypto carry diversify</a:t>
-                      </a:r>
-                    </a:p>
-                  </a:txBody>
-                  <a:tcPr marL="73152" marR="73152">
-                    <a:solidFill>
-                      <a:srgbClr val="FFFFFF"/>
-                    </a:solidFill>
-                  </a:tcPr>
-                </a:tc>
-                <a:tc>
-                  <a:txBody>
-                    <a:bodyPr/>
-                    <a:lstStyle/>
-                    <a:p>
-                      <a:pPr algn="l"/>
-                      <a:r>
-                        <a:rPr sz="1000" b="1">
-                          <a:solidFill>
-                            <a:srgbClr val="2E7D4F"/>
-                          </a:solidFill>
-                          <a:latin typeface="Calibri"/>
-                        </a:rPr>
-                        <a:t>Supported</a:t>
-                      </a:r>
-                    </a:p>
-                  </a:txBody>
-                  <a:tcPr marL="73152" marR="73152">
-                    <a:solidFill>
-                      <a:srgbClr val="FFFFFF"/>
-                    </a:solidFill>
-                  </a:tcPr>
-                </a:tc>
-                <a:tc>
-                  <a:txBody>
-                    <a:bodyPr/>
-                    <a:lstStyle/>
-                    <a:p>
-                      <a:pPr algn="l"/>
-                      <a:r>
-                        <a:rPr sz="1000" b="0">
-                          <a:solidFill>
-                            <a:srgbClr val="1B1F27"/>
-                          </a:solidFill>
-                          <a:latin typeface="Calibri"/>
-                        </a:rPr>
-                        <a:t>Correlation 0.11; vol 7.0% vs about 9%</a:t>
-                      </a:r>
-                    </a:p>
-                  </a:txBody>
-                  <a:tcPr marL="73152" marR="73152">
-                    <a:solidFill>
-                      <a:srgbClr val="FFFFFF"/>
                     </a:solidFill>
                   </a:tcPr>
                 </a:tc>
@@ -14939,22 +14853,6 @@
                 <a:latin typeface="Calibri"/>
               </a:rPr>
               <a:t>•  Its losses come from single coins: Terra lost 87 points, XRP 58 and Dogecoin 43.</a:t>
-            </a:r>
-          </a:p>
-          <a:p>
-            <a:pPr algn="l">
-              <a:spcAft>
-                <a:spcPts val="800"/>
-              </a:spcAft>
-            </a:pPr>
-            <a:r>
-              <a:rPr sz="1300" b="0" i="0">
-                <a:solidFill>
-                  <a:srgbClr val="1B1F27"/>
-                </a:solidFill>
-                <a:latin typeface="Calibri"/>
-              </a:rPr>
-              <a:t>•  Our pre-set risk control lowered the Sharpe from 0.14 to -0.16, so it did not help.</a:t>
             </a:r>
           </a:p>
           <a:p>

</xml_diff>